<commit_message>
Meeting deck: two slides deriving the EO response of lines A and B and the EO crosstalk vs NEXT/FEXT
EO crosstalk ~ delta/4 (launch, NEXT-like) + FEXT-like term averaged over the
light's path; checked against the twin to 0.1 dB (10-60 GHz, 14 mm). Test
bench slide states what is compared (modulation voltages via the ENA).

Co-Authored-By: Claude Opus 5.5 <noreply@anthropic.com>
Claude-Session: https://claude.ai/code/session_01PF7RKNjFsSkyjm1syGCUrV
</commit_message>
<xml_diff>
--- a/docs/cst/xtalk/crosstalk_meeting.pptx
+++ b/docs/cst/xtalk/crosstalk_meeting.pptx
@@ -22,6 +22,8 @@
     <p:sldId id="267" r:id="rId18"/>
     <p:sldId id="268" r:id="rId19"/>
     <p:sldId id="269" r:id="rId20"/>
+    <p:sldId id="270" r:id="rId21"/>
+    <p:sldId id="271" r:id="rId22"/>
   </p:sldIdLst>
   <p:sldSz cx="12192000" cy="6858000"/>
   <p:notesSz cx="6858000" cy="9144000"/>
@@ -4865,7 +4867,7 @@
                 </a:solidFill>
                 <a:latin typeface="Arial"/>
               </a:rPr>
-              <a:t>INTERCONNECT: the "Coupled TL" scripted element</a:t>
+              <a:t>EO response of lines A and B: derivation (1/2)</a:t>
             </a:r>
           </a:p>
         </p:txBody>
@@ -4904,69 +4906,21 @@
                 </a:solidFill>
                 <a:latin typeface="Arial"/>
               </a:rPr>
-              <a:t>The single-line TL element, computed twice (even, odd) and recombined</a:t>
-            </a:r>
-          </a:p>
-        </p:txBody>
-      </p:sp>
-      <p:sp>
-        <p:nvSpPr>
-          <p:cNvPr id="4" name="Rounded Rectangle 3"/>
-          <p:cNvSpPr/>
-          <p:nvPr/>
-        </p:nvSpPr>
-        <p:spPr>
-          <a:xfrm>
-            <a:off x="457200" y="1463040"/>
-            <a:ext cx="3291840" cy="1828800"/>
-          </a:xfrm>
-          <a:prstGeom prst="roundRect">
-            <a:avLst>
-              <a:gd name="adj" fmla="val 6000"/>
-            </a:avLst>
-          </a:prstGeom>
-          <a:solidFill>
-            <a:srgbClr val="F1F3F8"/>
-          </a:solidFill>
-          <a:ln w="15875">
-            <a:solidFill>
-              <a:srgbClr val="D9DCE3"/>
-            </a:solidFill>
-          </a:ln>
-          <a:effectLst/>
-        </p:spPr>
-        <p:style>
-          <a:lnRef idx="1">
-            <a:schemeClr val="accent1"/>
-          </a:lnRef>
-          <a:fillRef idx="3">
-            <a:schemeClr val="accent1"/>
-          </a:fillRef>
-          <a:effectRef idx="2">
-            <a:schemeClr val="accent1"/>
-          </a:effectRef>
-          <a:fontRef idx="minor">
-            <a:schemeClr val="lt1"/>
-          </a:fontRef>
-        </p:style>
-        <p:txBody>
-          <a:bodyPr rtlCol="0" anchor="ctr"/>
-          <a:lstStyle/>
-          <a:p>
-            <a:pPr algn="ctr"/>
-          </a:p>
-        </p:txBody>
-      </p:sp>
-      <p:sp>
-        <p:nvSpPr>
-          <p:cNvPr id="5" name="TextBox 4"/>
+              <a:t>Exact; this is what the twin and the INTERCONNECT element compute</a:t>
+            </a:r>
+          </a:p>
+        </p:txBody>
+      </p:sp>
+      <p:sp>
+        <p:nvSpPr>
+          <p:cNvPr id="4" name="TextBox 3"/>
           <p:cNvSpPr txBox="1"/>
           <p:nvPr/>
         </p:nvSpPr>
         <p:spPr>
           <a:xfrm>
-            <a:off x="548640" y="1536192"/>
-            <a:ext cx="3108960" cy="1737360"/>
+            <a:off x="548640" y="1417320"/>
+            <a:ext cx="11155680" cy="685800"/>
           </a:xfrm>
           <a:prstGeom prst="rect">
             <a:avLst/>
@@ -4981,171 +4935,124 @@
           <a:p>
             <a:pPr algn="l">
               <a:spcAft>
-                <a:spcPts val="200"/>
+                <a:spcPts val="400"/>
               </a:spcAft>
             </a:pPr>
             <a:r>
               <a:rPr sz="1400" b="1">
                 <a:solidFill>
-                  <a:srgbClr val="0E2268"/>
-                </a:solidFill>
-                <a:latin typeface="Arial"/>
-              </a:rPr>
-              <a:t>TL line element (existing)</a:t>
-            </a:r>
-          </a:p>
-          <a:p>
-            <a:pPr algn="l">
-              <a:spcAft>
-                <a:spcPts val="200"/>
-              </a:spcAft>
-            </a:pPr>
-            <a:r>
-              <a:rPr sz="1300" b="0">
-                <a:solidFill>
-                  <a:srgbClr val="1A1A1A"/>
-                </a:solidFill>
-                <a:latin typeface="Arial"/>
-              </a:rPr>
-              <a:t>1 table: f, loss, n, Re Z, Im Z</a:t>
-            </a:r>
-          </a:p>
-          <a:p>
-            <a:pPr algn="l">
-              <a:spcAft>
-                <a:spcPts val="200"/>
-              </a:spcAft>
-            </a:pPr>
-            <a:r>
-              <a:rPr sz="1300" b="0">
-                <a:solidFill>
-                  <a:srgbClr val="1A1A1A"/>
-                </a:solidFill>
-                <a:latin typeface="Arial"/>
-              </a:rPr>
-              <a:t>2 ports + modulation output</a:t>
-            </a:r>
-          </a:p>
-          <a:p>
-            <a:pPr algn="l">
-              <a:spcAft>
-                <a:spcPts val="200"/>
-              </a:spcAft>
-            </a:pPr>
-            <a:r>
-              <a:rPr sz="1300" b="0">
-                <a:solidFill>
-                  <a:srgbClr val="1A1A1A"/>
-                </a:solidFill>
-                <a:latin typeface="Arial"/>
-              </a:rPr>
-              <a:t>exact V(z) integral, no slicing</a:t>
-            </a:r>
-          </a:p>
-        </p:txBody>
-      </p:sp>
-      <p:sp>
-        <p:nvSpPr>
-          <p:cNvPr id="6" name="Right Arrow 5"/>
-          <p:cNvSpPr/>
-          <p:nvPr/>
-        </p:nvSpPr>
-        <p:spPr>
-          <a:xfrm>
-            <a:off x="3886200" y="2194560"/>
-            <a:ext cx="731520" cy="365760"/>
-          </a:xfrm>
-          <a:prstGeom prst="rightArrow">
+                  <a:srgbClr val="1A1A1A"/>
+                </a:solidFill>
+                <a:latin typeface="Arial"/>
+              </a:rPr>
+              <a:t>1. Modes decouple.</a:t>
+            </a:r>
+            <a:r>
+              <a:rPr sz="1400" b="0">
+                <a:solidFill>
+                  <a:srgbClr val="1A1A1A"/>
+                </a:solidFill>
+                <a:latin typeface="Arial"/>
+              </a:rPr>
+              <a:t> Both lines see the same terminations (Z</a:t>
+            </a:r>
+            <a:r>
+              <a:rPr sz="1400" b="0" baseline="-25000">
+                <a:solidFill>
+                  <a:srgbClr val="1A1A1A"/>
+                </a:solidFill>
+                <a:latin typeface="Arial"/>
+              </a:rPr>
+              <a:t>s</a:t>
+            </a:r>
+            <a:r>
+              <a:rPr sz="1400" b="0">
+                <a:solidFill>
+                  <a:srgbClr val="1A1A1A"/>
+                </a:solidFill>
+                <a:latin typeface="Arial"/>
+              </a:rPr>
+              <a:t> at the input: A's driver, B's idle driver; R</a:t>
+            </a:r>
+            <a:r>
+              <a:rPr sz="1400" b="0" baseline="-25000">
+                <a:solidFill>
+                  <a:srgbClr val="1A1A1A"/>
+                </a:solidFill>
+                <a:latin typeface="Arial"/>
+              </a:rPr>
+              <a:t>t</a:t>
+            </a:r>
+            <a:r>
+              <a:rPr sz="1400" b="0">
+                <a:solidFill>
+                  <a:srgbClr val="1A1A1A"/>
+                </a:solidFill>
+                <a:latin typeface="Arial"/>
+              </a:rPr>
+              <a:t> at the far end). The aggressor EMF E on A = E/2 even + E/2 odd, each on its own single line:</a:t>
+            </a:r>
+          </a:p>
+        </p:txBody>
+      </p:sp>
+      <p:pic>
+        <p:nvPicPr>
+          <p:cNvPr id="5" name="Picture 4" descr="eq_Vm.png"/>
+          <p:cNvPicPr>
+            <a:picLocks noChangeAspect="1"/>
+          </p:cNvPicPr>
+          <p:nvPr/>
+        </p:nvPicPr>
+        <p:blipFill>
+          <a:blip r:embed="rId2"/>
+          <a:stretch>
+            <a:fillRect/>
+          </a:stretch>
+        </p:blipFill>
+        <p:spPr>
+          <a:xfrm>
+            <a:off x="822960" y="2148840"/>
+            <a:ext cx="7379804" cy="457200"/>
+          </a:xfrm>
+          <a:prstGeom prst="rect">
             <a:avLst/>
           </a:prstGeom>
-          <a:solidFill>
-            <a:srgbClr val="5A606E"/>
-          </a:solidFill>
-          <a:ln>
-            <a:noFill/>
-          </a:ln>
-          <a:effectLst/>
-        </p:spPr>
-        <p:style>
-          <a:lnRef idx="1">
-            <a:schemeClr val="accent1"/>
-          </a:lnRef>
-          <a:fillRef idx="3">
-            <a:schemeClr val="accent1"/>
-          </a:fillRef>
-          <a:effectRef idx="2">
-            <a:schemeClr val="accent1"/>
-          </a:effectRef>
-          <a:fontRef idx="minor">
-            <a:schemeClr val="lt1"/>
-          </a:fontRef>
-        </p:style>
-        <p:txBody>
-          <a:bodyPr rtlCol="0" anchor="ctr"/>
-          <a:lstStyle/>
-          <a:p>
-            <a:pPr algn="ctr"/>
-          </a:p>
-        </p:txBody>
-      </p:sp>
-      <p:sp>
-        <p:nvSpPr>
-          <p:cNvPr id="7" name="Rounded Rectangle 6"/>
-          <p:cNvSpPr/>
-          <p:nvPr/>
-        </p:nvSpPr>
-        <p:spPr>
-          <a:xfrm>
-            <a:off x="4754880" y="1463040"/>
-            <a:ext cx="3291840" cy="1828800"/>
-          </a:xfrm>
-          <a:prstGeom prst="roundRect">
-            <a:avLst>
-              <a:gd name="adj" fmla="val 6000"/>
-            </a:avLst>
-          </a:prstGeom>
-          <a:solidFill>
-            <a:srgbClr val="FDECEE"/>
-          </a:solidFill>
-          <a:ln w="15875">
-            <a:solidFill>
-              <a:srgbClr val="D9DCE3"/>
-            </a:solidFill>
-          </a:ln>
-          <a:effectLst/>
-        </p:spPr>
-        <p:style>
-          <a:lnRef idx="1">
-            <a:schemeClr val="accent1"/>
-          </a:lnRef>
-          <a:fillRef idx="3">
-            <a:schemeClr val="accent1"/>
-          </a:fillRef>
-          <a:effectRef idx="2">
-            <a:schemeClr val="accent1"/>
-          </a:effectRef>
-          <a:fontRef idx="minor">
-            <a:schemeClr val="lt1"/>
-          </a:fontRef>
-        </p:style>
-        <p:txBody>
-          <a:bodyPr rtlCol="0" anchor="ctr"/>
-          <a:lstStyle/>
-          <a:p>
-            <a:pPr algn="ctr"/>
-          </a:p>
-        </p:txBody>
-      </p:sp>
-      <p:sp>
-        <p:nvSpPr>
-          <p:cNvPr id="8" name="TextBox 7"/>
+        </p:spPr>
+      </p:pic>
+      <p:pic>
+        <p:nvPicPr>
+          <p:cNvPr id="6" name="Picture 5" descr="eq_Vplus.png"/>
+          <p:cNvPicPr>
+            <a:picLocks noChangeAspect="1"/>
+          </p:cNvPicPr>
+          <p:nvPr/>
+        </p:nvPicPr>
+        <p:blipFill>
+          <a:blip r:embed="rId3"/>
+          <a:stretch>
+            <a:fillRect/>
+          </a:stretch>
+        </p:blipFill>
+        <p:spPr>
+          <a:xfrm>
+            <a:off x="822960" y="2697480"/>
+            <a:ext cx="7946683" cy="566928"/>
+          </a:xfrm>
+          <a:prstGeom prst="rect">
+            <a:avLst/>
+          </a:prstGeom>
+        </p:spPr>
+      </p:pic>
+      <p:sp>
+        <p:nvSpPr>
+          <p:cNvPr id="7" name="TextBox 6"/>
           <p:cNvSpPr txBox="1"/>
           <p:nvPr/>
         </p:nvSpPr>
         <p:spPr>
           <a:xfrm>
-            <a:off x="4846320" y="1536192"/>
-            <a:ext cx="3108960" cy="1737360"/>
+            <a:off x="548640" y="3383280"/>
+            <a:ext cx="11155680" cy="685800"/>
           </a:xfrm>
           <a:prstGeom prst="rect">
             <a:avLst/>
@@ -5160,125 +5067,118 @@
           <a:p>
             <a:pPr algn="l">
               <a:spcAft>
-                <a:spcPts val="200"/>
+                <a:spcPts val="400"/>
               </a:spcAft>
             </a:pPr>
             <a:r>
               <a:rPr sz="1400" b="1">
                 <a:solidFill>
-                  <a:srgbClr val="F20013"/>
-                </a:solidFill>
-                <a:latin typeface="Arial"/>
-              </a:rPr>
-              <a:t>Coupled TL element (new)</a:t>
-            </a:r>
-          </a:p>
-          <a:p>
-            <a:pPr algn="l">
-              <a:spcAft>
-                <a:spcPts val="200"/>
-              </a:spcAft>
-            </a:pPr>
-            <a:r>
-              <a:rPr sz="1300" b="0">
-                <a:solidFill>
-                  <a:srgbClr val="1A1A1A"/>
-                </a:solidFill>
-                <a:latin typeface="Arial"/>
-              </a:rPr>
-              <a:t>2 tables: coupled_even/odd.txt</a:t>
-            </a:r>
-          </a:p>
-          <a:p>
-            <a:pPr algn="l">
-              <a:spcAft>
-                <a:spcPts val="200"/>
-              </a:spcAft>
-            </a:pPr>
-            <a:r>
-              <a:rPr sz="1300" b="0">
-                <a:solidFill>
-                  <a:srgbClr val="1A1A1A"/>
-                </a:solidFill>
-                <a:latin typeface="Arial"/>
-              </a:rPr>
-              <a:t>ports A1, A2, B1, B2</a:t>
-            </a:r>
-          </a:p>
-          <a:p>
-            <a:pPr algn="l">
-              <a:spcAft>
-                <a:spcPts val="200"/>
-              </a:spcAft>
-            </a:pPr>
-            <a:r>
-              <a:rPr sz="1300" b="0">
-                <a:solidFill>
-                  <a:srgbClr val="1A1A1A"/>
-                </a:solidFill>
-                <a:latin typeface="Arial"/>
-              </a:rPr>
-              <a:t>modulation A, B (+ 2 A, 2 B), far/near end</a:t>
-            </a:r>
-          </a:p>
-        </p:txBody>
-      </p:sp>
-      <p:sp>
-        <p:nvSpPr>
-          <p:cNvPr id="9" name="Rounded Rectangle 8"/>
-          <p:cNvSpPr/>
-          <p:nvPr/>
-        </p:nvSpPr>
-        <p:spPr>
-          <a:xfrm>
-            <a:off x="8229600" y="1463040"/>
-            <a:ext cx="3520440" cy="1828800"/>
-          </a:xfrm>
-          <a:prstGeom prst="roundRect">
-            <a:avLst>
-              <a:gd name="adj" fmla="val 6000"/>
-            </a:avLst>
-          </a:prstGeom>
-          <a:solidFill>
-            <a:srgbClr val="F1F3F8"/>
-          </a:solidFill>
-          <a:ln>
-            <a:noFill/>
-          </a:ln>
-          <a:effectLst/>
-        </p:spPr>
-        <p:style>
-          <a:lnRef idx="1">
-            <a:schemeClr val="accent1"/>
-          </a:lnRef>
-          <a:fillRef idx="3">
-            <a:schemeClr val="accent1"/>
-          </a:fillRef>
-          <a:effectRef idx="2">
-            <a:schemeClr val="accent1"/>
-          </a:effectRef>
-          <a:fontRef idx="minor">
-            <a:schemeClr val="lt1"/>
-          </a:fontRef>
-        </p:style>
-        <p:txBody>
-          <a:bodyPr rtlCol="0" anchor="ctr"/>
-          <a:lstStyle/>
-          <a:p>
-            <a:pPr algn="ctr"/>
-          </a:p>
-        </p:txBody>
-      </p:sp>
-      <p:sp>
-        <p:nvSpPr>
-          <p:cNvPr id="10" name="TextBox 9"/>
+                  <a:srgbClr val="1A1A1A"/>
+                </a:solidFill>
+                <a:latin typeface="Arial"/>
+              </a:rPr>
+              <a:t>2. What the light integrates.</a:t>
+            </a:r>
+            <a:r>
+              <a:rPr sz="1400" b="0">
+                <a:solidFill>
+                  <a:srgbClr val="1A1A1A"/>
+                </a:solidFill>
+                <a:latin typeface="Arial"/>
+              </a:rPr>
+              <a:t> The optical wave travels at c/n</a:t>
+            </a:r>
+            <a:r>
+              <a:rPr sz="1400" b="0" baseline="-25000">
+                <a:solidFill>
+                  <a:srgbClr val="1A1A1A"/>
+                </a:solidFill>
+                <a:latin typeface="Arial"/>
+              </a:rPr>
+              <a:t>g</a:t>
+            </a:r>
+            <a:r>
+              <a:rPr sz="1400" b="0">
+                <a:solidFill>
+                  <a:srgbClr val="1A1A1A"/>
+                </a:solidFill>
+                <a:latin typeface="Arial"/>
+              </a:rPr>
+              <a:t>, so each mode's voltage is averaged in the frame of the light. Closed form, forward (V</a:t>
+            </a:r>
+            <a:r>
+              <a:rPr sz="1400" b="0" baseline="30000">
+                <a:solidFill>
+                  <a:srgbClr val="1A1A1A"/>
+                </a:solidFill>
+                <a:latin typeface="Arial"/>
+              </a:rPr>
+              <a:t>+</a:t>
+            </a:r>
+            <a:r>
+              <a:rPr sz="1400" b="0">
+                <a:solidFill>
+                  <a:srgbClr val="1A1A1A"/>
+                </a:solidFill>
+                <a:latin typeface="Arial"/>
+              </a:rPr>
+              <a:t>) and backward (V</a:t>
+            </a:r>
+            <a:r>
+              <a:rPr sz="1400" b="0" baseline="30000">
+                <a:solidFill>
+                  <a:srgbClr val="1A1A1A"/>
+                </a:solidFill>
+                <a:latin typeface="Arial"/>
+              </a:rPr>
+              <a:t>−</a:t>
+            </a:r>
+            <a:r>
+              <a:rPr sz="1400" b="0">
+                <a:solidFill>
+                  <a:srgbClr val="1A1A1A"/>
+                </a:solidFill>
+                <a:latin typeface="Arial"/>
+              </a:rPr>
+              <a:t>) parts:</a:t>
+            </a:r>
+          </a:p>
+        </p:txBody>
+      </p:sp>
+      <p:pic>
+        <p:nvPicPr>
+          <p:cNvPr id="8" name="Picture 7" descr="eq_Hm.png"/>
+          <p:cNvPicPr>
+            <a:picLocks noChangeAspect="1"/>
+          </p:cNvPicPr>
+          <p:nvPr/>
+        </p:nvPicPr>
+        <p:blipFill>
+          <a:blip r:embed="rId4"/>
+          <a:stretch>
+            <a:fillRect/>
+          </a:stretch>
+        </p:blipFill>
+        <p:spPr>
+          <a:xfrm>
+            <a:off x="822960" y="4069080"/>
+            <a:ext cx="9108643" cy="566928"/>
+          </a:xfrm>
+          <a:prstGeom prst="rect">
+            <a:avLst/>
+          </a:prstGeom>
+        </p:spPr>
+      </p:pic>
+      <p:sp>
+        <p:nvSpPr>
+          <p:cNvPr id="9" name="TextBox 8"/>
           <p:cNvSpPr txBox="1"/>
           <p:nvPr/>
         </p:nvSpPr>
         <p:spPr>
           <a:xfrm>
-            <a:off x="8366760" y="1536192"/>
-            <a:ext cx="3246120" cy="1719072"/>
+            <a:off x="548640" y="4800600"/>
+            <a:ext cx="11155680" cy="411480"/>
           </a:xfrm>
           <a:prstGeom prst="rect">
             <a:avLst/>
@@ -5293,197 +5193,64 @@
           <a:p>
             <a:pPr algn="l">
               <a:spcAft>
-                <a:spcPts val="300"/>
-              </a:spcAft>
-            </a:pPr>
-            <a:r>
-              <a:rPr sz="1500" b="1">
-                <a:solidFill>
-                  <a:srgbClr val="0E2268"/>
-                </a:solidFill>
-                <a:latin typeface="Arial"/>
-              </a:rPr>
-              <a:t>Recombination</a:t>
-            </a:r>
-          </a:p>
-          <a:p>
-            <a:pPr algn="l">
-              <a:spcAft>
-                <a:spcPts val="300"/>
-              </a:spcAft>
-            </a:pPr>
-            <a:r>
-              <a:rPr sz="1350" b="0">
-                <a:solidFill>
-                  <a:srgbClr val="1A1A1A"/>
-                </a:solidFill>
-                <a:latin typeface="Arial"/>
-              </a:rPr>
-              <a:t>S own line = ½(S</a:t>
-            </a:r>
-            <a:r>
-              <a:rPr sz="1350" b="0" baseline="30000">
-                <a:solidFill>
-                  <a:srgbClr val="1A1A1A"/>
-                </a:solidFill>
-                <a:latin typeface="Arial"/>
-              </a:rPr>
-              <a:t>e</a:t>
-            </a:r>
-            <a:r>
-              <a:rPr sz="1350" b="0">
-                <a:solidFill>
-                  <a:srgbClr val="1A1A1A"/>
-                </a:solidFill>
-                <a:latin typeface="Arial"/>
-              </a:rPr>
-              <a:t> + S</a:t>
-            </a:r>
-            <a:r>
-              <a:rPr sz="1350" b="0" baseline="30000">
-                <a:solidFill>
-                  <a:srgbClr val="1A1A1A"/>
-                </a:solidFill>
-                <a:latin typeface="Arial"/>
-              </a:rPr>
-              <a:t>o</a:t>
-            </a:r>
-            <a:r>
-              <a:rPr sz="1350" b="0">
-                <a:solidFill>
-                  <a:srgbClr val="1A1A1A"/>
-                </a:solidFill>
-                <a:latin typeface="Arial"/>
-              </a:rPr>
-              <a:t>)</a:t>
-            </a:r>
-          </a:p>
-          <a:p>
-            <a:pPr algn="l">
-              <a:spcAft>
-                <a:spcPts val="300"/>
-              </a:spcAft>
-            </a:pPr>
-            <a:r>
-              <a:rPr sz="1350" b="0">
-                <a:solidFill>
-                  <a:srgbClr val="1A1A1A"/>
-                </a:solidFill>
-                <a:latin typeface="Arial"/>
-              </a:rPr>
-              <a:t>S other line = ½(S</a:t>
-            </a:r>
-            <a:r>
-              <a:rPr sz="1350" b="0" baseline="30000">
-                <a:solidFill>
-                  <a:srgbClr val="1A1A1A"/>
-                </a:solidFill>
-                <a:latin typeface="Arial"/>
-              </a:rPr>
-              <a:t>e</a:t>
-            </a:r>
-            <a:r>
-              <a:rPr sz="1350" b="0">
-                <a:solidFill>
-                  <a:srgbClr val="1A1A1A"/>
-                </a:solidFill>
-                <a:latin typeface="Arial"/>
-              </a:rPr>
-              <a:t> − S</a:t>
-            </a:r>
-            <a:r>
-              <a:rPr sz="1350" b="0" baseline="30000">
-                <a:solidFill>
-                  <a:srgbClr val="1A1A1A"/>
-                </a:solidFill>
-                <a:latin typeface="Arial"/>
-              </a:rPr>
-              <a:t>o</a:t>
-            </a:r>
-            <a:r>
-              <a:rPr sz="1350" b="0">
-                <a:solidFill>
-                  <a:srgbClr val="1A1A1A"/>
-                </a:solidFill>
-                <a:latin typeface="Arial"/>
-              </a:rPr>
-              <a:t>)</a:t>
-            </a:r>
-          </a:p>
-          <a:p>
-            <a:pPr algn="l">
-              <a:spcAft>
-                <a:spcPts val="300"/>
-              </a:spcAft>
-            </a:pPr>
-            <a:r>
-              <a:rPr sz="1350" b="0">
-                <a:solidFill>
-                  <a:srgbClr val="1A1A1A"/>
-                </a:solidFill>
-                <a:latin typeface="Arial"/>
-              </a:rPr>
-              <a:t>same for the modulation outputs</a:t>
-            </a:r>
-          </a:p>
-        </p:txBody>
-      </p:sp>
-      <p:sp>
-        <p:nvSpPr>
-          <p:cNvPr id="11" name="Rounded Rectangle 10"/>
-          <p:cNvSpPr/>
-          <p:nvPr/>
-        </p:nvSpPr>
-        <p:spPr>
-          <a:xfrm>
-            <a:off x="457200" y="3520440"/>
-            <a:ext cx="5532120" cy="2788920"/>
-          </a:xfrm>
-          <a:prstGeom prst="roundRect">
-            <a:avLst>
-              <a:gd name="adj" fmla="val 6000"/>
-            </a:avLst>
-          </a:prstGeom>
-          <a:solidFill>
-            <a:srgbClr val="F1F3F8"/>
-          </a:solidFill>
-          <a:ln>
-            <a:noFill/>
-          </a:ln>
-          <a:effectLst/>
-        </p:spPr>
-        <p:style>
-          <a:lnRef idx="1">
-            <a:schemeClr val="accent1"/>
-          </a:lnRef>
-          <a:fillRef idx="3">
-            <a:schemeClr val="accent1"/>
-          </a:fillRef>
-          <a:effectRef idx="2">
-            <a:schemeClr val="accent1"/>
-          </a:effectRef>
-          <a:fontRef idx="minor">
-            <a:schemeClr val="lt1"/>
-          </a:fontRef>
-        </p:style>
-        <p:txBody>
-          <a:bodyPr rtlCol="0" anchor="ctr"/>
-          <a:lstStyle/>
-          <a:p>
-            <a:pPr algn="ctr"/>
-          </a:p>
-        </p:txBody>
-      </p:sp>
-      <p:sp>
-        <p:nvSpPr>
-          <p:cNvPr id="12" name="TextBox 11"/>
+                <a:spcPts val="400"/>
+              </a:spcAft>
+            </a:pPr>
+            <a:r>
+              <a:rPr sz="1400" b="1">
+                <a:solidFill>
+                  <a:srgbClr val="1A1A1A"/>
+                </a:solidFill>
+                <a:latin typeface="Arial"/>
+              </a:rPr>
+              <a:t>3. Back to the lines</a:t>
+            </a:r>
+            <a:r>
+              <a:rPr sz="1400" b="0">
+                <a:solidFill>
+                  <a:srgbClr val="1A1A1A"/>
+                </a:solidFill>
+                <a:latin typeface="Arial"/>
+              </a:rPr>
+              <a:t> (same recombination as for the S-parameters):</a:t>
+            </a:r>
+          </a:p>
+        </p:txBody>
+      </p:sp>
+      <p:pic>
+        <p:nvPicPr>
+          <p:cNvPr id="10" name="Picture 9" descr="eq_HAB.png"/>
+          <p:cNvPicPr>
+            <a:picLocks noChangeAspect="1"/>
+          </p:cNvPicPr>
+          <p:nvPr/>
+        </p:nvPicPr>
+        <p:blipFill>
+          <a:blip r:embed="rId5"/>
+          <a:stretch>
+            <a:fillRect/>
+          </a:stretch>
+        </p:blipFill>
+        <p:spPr>
+          <a:xfrm>
+            <a:off x="822960" y="5257800"/>
+            <a:ext cx="9844922" cy="566928"/>
+          </a:xfrm>
+          <a:prstGeom prst="rect">
+            <a:avLst/>
+          </a:prstGeom>
+        </p:spPr>
+      </p:pic>
+      <p:sp>
+        <p:nvSpPr>
+          <p:cNvPr id="11" name="TextBox 10"/>
           <p:cNvSpPr txBox="1"/>
           <p:nvPr/>
         </p:nvSpPr>
         <p:spPr>
           <a:xfrm>
-            <a:off x="594360" y="3593592"/>
-            <a:ext cx="5257800" cy="2679191"/>
+            <a:off x="548640" y="5989320"/>
+            <a:ext cx="11155680" cy="365760"/>
           </a:xfrm>
           <a:prstGeom prst="rect">
             <a:avLst/>
@@ -5498,236 +5265,161 @@
           <a:p>
             <a:pPr algn="l">
               <a:spcAft>
-                <a:spcPts val="300"/>
-              </a:spcAft>
-            </a:pPr>
-            <a:r>
-              <a:rPr sz="1500" b="1">
-                <a:solidFill>
-                  <a:srgbClr val="0E2268"/>
-                </a:solidFill>
-                <a:latin typeface="Arial"/>
-              </a:rPr>
-              <a:t>Tables coupled_even.txt / coupled_odd.txt</a:t>
-            </a:r>
-          </a:p>
-          <a:p>
-            <a:pPr algn="l">
-              <a:spcAft>
-                <a:spcPts val="300"/>
-              </a:spcAft>
-            </a:pPr>
-            <a:r>
-              <a:rPr sz="1350" b="0">
-                <a:solidFill>
-                  <a:srgbClr val="1A1A1A"/>
-                </a:solidFill>
-                <a:latin typeface="Arial"/>
-              </a:rPr>
-              <a:t>Columns: frequency (Hz), loss (dB/m), microwave index, Re Z</a:t>
-            </a:r>
-            <a:r>
-              <a:rPr sz="1350" b="0" baseline="-25000">
-                <a:solidFill>
-                  <a:srgbClr val="1A1A1A"/>
+                <a:spcPts val="400"/>
+              </a:spcAft>
+            </a:pPr>
+            <a:r>
+              <a:rPr sz="1200" b="0">
+                <a:solidFill>
+                  <a:srgbClr val="5A606E"/>
+                </a:solidFill>
+                <a:latin typeface="Arial"/>
+              </a:rPr>
+              <a:t>V</a:t>
+            </a:r>
+            <a:r>
+              <a:rPr sz="1200" b="0" baseline="-25000">
+                <a:solidFill>
+                  <a:srgbClr val="5A606E"/>
+                </a:solidFill>
+                <a:latin typeface="Arial"/>
+              </a:rPr>
+              <a:t>m</a:t>
+            </a:r>
+            <a:r>
+              <a:rPr sz="1200" b="0" baseline="30000">
+                <a:solidFill>
+                  <a:srgbClr val="5A606E"/>
+                </a:solidFill>
+                <a:latin typeface="Arial"/>
+              </a:rPr>
+              <a:t>−</a:t>
+            </a:r>
+            <a:r>
+              <a:rPr sz="1200" b="0">
+                <a:solidFill>
+                  <a:srgbClr val="5A606E"/>
+                </a:solidFill>
+                <a:latin typeface="Arial"/>
+              </a:rPr>
+              <a:t> = Γ</a:t>
+            </a:r>
+            <a:r>
+              <a:rPr sz="1200" b="0" baseline="-25000">
+                <a:solidFill>
+                  <a:srgbClr val="5A606E"/>
+                </a:solidFill>
+                <a:latin typeface="Arial"/>
+              </a:rPr>
+              <a:t>t,m</a:t>
+            </a:r>
+            <a:r>
+              <a:rPr sz="1200" b="0">
+                <a:solidFill>
+                  <a:srgbClr val="5A606E"/>
+                </a:solidFill>
+                <a:latin typeface="Arial"/>
+              </a:rPr>
+              <a:t> · exp(−2γ</a:t>
+            </a:r>
+            <a:r>
+              <a:rPr sz="1200" b="0" baseline="-25000">
+                <a:solidFill>
+                  <a:srgbClr val="5A606E"/>
+                </a:solidFill>
+                <a:latin typeface="Arial"/>
+              </a:rPr>
+              <a:t>m</a:t>
+            </a:r>
+            <a:r>
+              <a:rPr sz="1200" b="0">
+                <a:solidFill>
+                  <a:srgbClr val="5A606E"/>
+                </a:solidFill>
+                <a:latin typeface="Arial"/>
+              </a:rPr>
+              <a:t>L) · V</a:t>
+            </a:r>
+            <a:r>
+              <a:rPr sz="1200" b="0" baseline="-25000">
+                <a:solidFill>
+                  <a:srgbClr val="5A606E"/>
+                </a:solidFill>
+                <a:latin typeface="Arial"/>
+              </a:rPr>
+              <a:t>m</a:t>
+            </a:r>
+            <a:r>
+              <a:rPr sz="1200" b="0" baseline="30000">
+                <a:solidFill>
+                  <a:srgbClr val="5A606E"/>
+                </a:solidFill>
+                <a:latin typeface="Arial"/>
+              </a:rPr>
+              <a:t>+</a:t>
+            </a:r>
+            <a:r>
+              <a:rPr sz="1200" b="0">
+                <a:solidFill>
+                  <a:srgbClr val="5A606E"/>
+                </a:solidFill>
+                <a:latin typeface="Arial"/>
+              </a:rPr>
+              <a:t>;  β</a:t>
+            </a:r>
+            <a:r>
+              <a:rPr sz="1200" b="0" baseline="-25000">
+                <a:solidFill>
+                  <a:srgbClr val="5A606E"/>
+                </a:solidFill>
+                <a:latin typeface="Arial"/>
+              </a:rPr>
+              <a:t>o</a:t>
+            </a:r>
+            <a:r>
+              <a:rPr sz="1200" b="0">
+                <a:solidFill>
+                  <a:srgbClr val="5A606E"/>
+                </a:solidFill>
+                <a:latin typeface="Arial"/>
+              </a:rPr>
+              <a:t> = 2πf n</a:t>
+            </a:r>
+            <a:r>
+              <a:rPr sz="1200" b="0" baseline="-25000">
+                <a:solidFill>
+                  <a:srgbClr val="5A606E"/>
+                </a:solidFill>
+                <a:latin typeface="Arial"/>
+              </a:rPr>
+              <a:t>g</a:t>
+            </a:r>
+            <a:r>
+              <a:rPr sz="1200" b="0">
+                <a:solidFill>
+                  <a:srgbClr val="5A606E"/>
+                </a:solidFill>
+                <a:latin typeface="Arial"/>
+              </a:rPr>
+              <a:t>/c. Electrical S-parameters (NEXT, FEXT) use the same modal waves with z</a:t>
+            </a:r>
+            <a:r>
+              <a:rPr sz="1200" b="0" baseline="-25000">
+                <a:solidFill>
+                  <a:srgbClr val="5A606E"/>
                 </a:solidFill>
                 <a:latin typeface="Arial"/>
               </a:rPr>
               <a:t>0</a:t>
             </a:r>
             <a:r>
-              <a:rPr sz="1350" b="0">
-                <a:solidFill>
-                  <a:srgbClr val="1A1A1A"/>
-                </a:solidFill>
-                <a:latin typeface="Arial"/>
-              </a:rPr>
-              <a:t>, Im Z</a:t>
-            </a:r>
-            <a:r>
-              <a:rPr sz="1350" b="0" baseline="-25000">
-                <a:solidFill>
-                  <a:srgbClr val="1A1A1A"/>
-                </a:solidFill>
-                <a:latin typeface="Arial"/>
-              </a:rPr>
-              <a:t>0</a:t>
-            </a:r>
-            <a:r>
-              <a:rPr sz="1350" b="0">
-                <a:solidFill>
-                  <a:srgbClr val="1A1A1A"/>
-                </a:solidFill>
-                <a:latin typeface="Arial"/>
-              </a:rPr>
-              <a:t> (Ω).</a:t>
-            </a:r>
-          </a:p>
-          <a:p>
-            <a:pPr algn="l">
-              <a:spcAft>
-                <a:spcPts val="300"/>
-              </a:spcAft>
-            </a:pPr>
-            <a:r>
-              <a:rPr sz="1350" b="0">
-                <a:solidFill>
-                  <a:srgbClr val="1A1A1A"/>
-                </a:solidFill>
-                <a:latin typeface="Arial"/>
-              </a:rPr>
-              <a:t>Written by the GUI ("Export tables"): 3-D line fit ± the split (Δn × 1.146, δ = 0.61 %).</a:t>
-            </a:r>
-          </a:p>
-          <a:p>
-            <a:pPr algn="l">
-              <a:spcAft>
-                <a:spcPts val="300"/>
-              </a:spcAft>
-            </a:pPr>
-            <a:r>
-              <a:rPr sz="1350" b="0">
-                <a:solidFill>
-                  <a:srgbClr val="1A1A1A"/>
-                </a:solidFill>
-                <a:latin typeface="Arial"/>
-              </a:rPr>
-              <a:t>0.05 GHz to the Nyquist frequency; above 60 GHz, extrapolated with the single-line fit forms.</a:t>
-            </a:r>
-          </a:p>
-        </p:txBody>
-      </p:sp>
-      <p:sp>
-        <p:nvSpPr>
-          <p:cNvPr id="13" name="Rounded Rectangle 12"/>
-          <p:cNvSpPr/>
-          <p:nvPr/>
-        </p:nvSpPr>
-        <p:spPr>
-          <a:xfrm>
-            <a:off x="6199632" y="3520440"/>
-            <a:ext cx="5550408" cy="2788920"/>
-          </a:xfrm>
-          <a:prstGeom prst="roundRect">
-            <a:avLst>
-              <a:gd name="adj" fmla="val 6000"/>
-            </a:avLst>
-          </a:prstGeom>
-          <a:solidFill>
-            <a:srgbClr val="F1F3F8"/>
-          </a:solidFill>
-          <a:ln>
-            <a:noFill/>
-          </a:ln>
-          <a:effectLst/>
-        </p:spPr>
-        <p:style>
-          <a:lnRef idx="1">
-            <a:schemeClr val="accent1"/>
-          </a:lnRef>
-          <a:fillRef idx="3">
-            <a:schemeClr val="accent1"/>
-          </a:fillRef>
-          <a:effectRef idx="2">
-            <a:schemeClr val="accent1"/>
-          </a:effectRef>
-          <a:fontRef idx="minor">
-            <a:schemeClr val="lt1"/>
-          </a:fontRef>
-        </p:style>
-        <p:txBody>
-          <a:bodyPr rtlCol="0" anchor="ctr"/>
-          <a:lstStyle/>
-          <a:p>
-            <a:pPr algn="ctr"/>
-          </a:p>
-        </p:txBody>
-      </p:sp>
-      <p:sp>
-        <p:nvSpPr>
-          <p:cNvPr id="14" name="TextBox 13"/>
-          <p:cNvSpPr txBox="1"/>
-          <p:nvPr/>
-        </p:nvSpPr>
-        <p:spPr>
-          <a:xfrm>
-            <a:off x="6336792" y="3593592"/>
-            <a:ext cx="5276088" cy="2679191"/>
-          </a:xfrm>
-          <a:prstGeom prst="rect">
-            <a:avLst/>
-          </a:prstGeom>
-          <a:noFill/>
-        </p:spPr>
-        <p:txBody>
-          <a:bodyPr wrap="square" lIns="36576" rIns="36576" tIns="18288" bIns="18288" anchor="t">
-            <a:spAutoFit/>
-          </a:bodyPr>
-          <a:lstStyle/>
-          <a:p>
-            <a:pPr algn="l">
-              <a:spcAft>
-                <a:spcPts val="300"/>
-              </a:spcAft>
-            </a:pPr>
-            <a:r>
-              <a:rPr sz="1500" b="1">
-                <a:solidFill>
-                  <a:srgbClr val="0E2268"/>
-                </a:solidFill>
-                <a:latin typeface="Arial"/>
-              </a:rPr>
-              <a:t>Code check</a:t>
-            </a:r>
-          </a:p>
-          <a:p>
-            <a:pPr algn="l">
-              <a:spcAft>
-                <a:spcPts val="300"/>
-              </a:spcAft>
-            </a:pPr>
-            <a:r>
-              <a:rPr sz="1350" b="0">
-                <a:solidFill>
-                  <a:srgbClr val="1A1A1A"/>
-                </a:solidFill>
-                <a:latin typeface="Arial"/>
-              </a:rPr>
-              <a:t>LSF code executed line by line vs Python twin: ≤ 4.5·10</a:t>
-            </a:r>
-            <a:r>
-              <a:rPr sz="1350" b="0" baseline="30000">
-                <a:solidFill>
-                  <a:srgbClr val="1A1A1A"/>
-                </a:solidFill>
-                <a:latin typeface="Arial"/>
-              </a:rPr>
-              <a:t>−14</a:t>
-            </a:r>
-            <a:r>
-              <a:rPr sz="1350" b="0">
-                <a:solidFill>
-                  <a:srgbClr val="1A1A1A"/>
-                </a:solidFill>
-                <a:latin typeface="Arial"/>
-              </a:rPr>
-              <a:t>.</a:t>
-            </a:r>
-          </a:p>
-          <a:p>
-            <a:pPr algn="l">
-              <a:spcAft>
-                <a:spcPts val="300"/>
-              </a:spcAft>
-            </a:pPr>
-            <a:r>
-              <a:rPr sz="1350" b="0">
-                <a:solidFill>
-                  <a:srgbClr val="1A1A1A"/>
-                </a:solidFill>
-                <a:latin typeface="Arial"/>
-              </a:rPr>
-              <a:t>INTERCONNECT run (14 mm): aggressor within 0.09 dB / 0.44°; crosstalk error 72–84 dB below the aggressor.</a:t>
+              <a:rPr sz="1200" b="0">
+                <a:solidFill>
+                  <a:srgbClr val="5A606E"/>
+                </a:solidFill>
+                <a:latin typeface="Arial"/>
+              </a:rPr>
+              <a:t> = 50 Ω terminations.</a:t>
             </a:r>
           </a:p>
         </p:txBody>
@@ -5784,7 +5476,7 @@
                 </a:solidFill>
                 <a:latin typeface="Arial"/>
               </a:rPr>
-              <a:t>INTERCONNECT test bench (PAIR_MOD / FE / NE)</a:t>
+              <a:t>EO crosstalk vs NEXT and FEXT: derivation (2/2)</a:t>
             </a:r>
           </a:p>
         </p:txBody>
@@ -5823,599 +5515,81 @@
                 </a:solidFill>
                 <a:latin typeface="Arial"/>
               </a:rPr>
-              <a:t>Isolates the element: driver, idle victim driver, two terminations, analyser</a:t>
-            </a:r>
-          </a:p>
-        </p:txBody>
-      </p:sp>
-      <p:sp>
-        <p:nvSpPr>
-          <p:cNvPr id="4" name="Rounded Rectangle 3"/>
-          <p:cNvSpPr/>
-          <p:nvPr/>
-        </p:nvSpPr>
-        <p:spPr>
-          <a:xfrm>
-            <a:off x="457200" y="1508760"/>
-            <a:ext cx="2606040" cy="1234440"/>
-          </a:xfrm>
-          <a:prstGeom prst="roundRect">
-            <a:avLst>
-              <a:gd name="adj" fmla="val 6000"/>
-            </a:avLst>
-          </a:prstGeom>
-          <a:solidFill>
-            <a:srgbClr val="F1F3F8"/>
-          </a:solidFill>
-          <a:ln w="15875">
-            <a:solidFill>
-              <a:srgbClr val="D9DCE3"/>
-            </a:solidFill>
-          </a:ln>
-          <a:effectLst/>
-        </p:spPr>
-        <p:style>
-          <a:lnRef idx="1">
-            <a:schemeClr val="accent1"/>
-          </a:lnRef>
-          <a:fillRef idx="3">
-            <a:schemeClr val="accent1"/>
-          </a:fillRef>
-          <a:effectRef idx="2">
-            <a:schemeClr val="accent1"/>
-          </a:effectRef>
-          <a:fontRef idx="minor">
-            <a:schemeClr val="lt1"/>
-          </a:fontRef>
-        </p:style>
-        <p:txBody>
-          <a:bodyPr rtlCol="0" anchor="ctr"/>
-          <a:lstStyle/>
-          <a:p>
-            <a:pPr algn="ctr"/>
-          </a:p>
-        </p:txBody>
-      </p:sp>
-      <p:sp>
-        <p:nvSpPr>
-          <p:cNvPr id="5" name="TextBox 4"/>
-          <p:cNvSpPr txBox="1"/>
-          <p:nvPr/>
-        </p:nvSpPr>
-        <p:spPr>
-          <a:xfrm>
-            <a:off x="548640" y="1581912"/>
-            <a:ext cx="2423160" cy="1143000"/>
+              <a:t>First order in δ and Δβ, terminations matched to the line (Z</a:t>
+            </a:r>
+            <a:r>
+              <a:rPr sz="1500" b="1" baseline="-25000">
+                <a:solidFill>
+                  <a:srgbClr val="0E2268"/>
+                </a:solidFill>
+                <a:latin typeface="Arial"/>
+              </a:rPr>
+              <a:t>s</a:t>
+            </a:r>
+            <a:r>
+              <a:rPr sz="1500" b="1">
+                <a:solidFill>
+                  <a:srgbClr val="0E2268"/>
+                </a:solidFill>
+                <a:latin typeface="Arial"/>
+              </a:rPr>
+              <a:t> = R</a:t>
+            </a:r>
+            <a:r>
+              <a:rPr sz="1500" b="1" baseline="-25000">
+                <a:solidFill>
+                  <a:srgbClr val="0E2268"/>
+                </a:solidFill>
+                <a:latin typeface="Arial"/>
+              </a:rPr>
+              <a:t>t</a:t>
+            </a:r>
+            <a:r>
+              <a:rPr sz="1500" b="1">
+                <a:solidFill>
+                  <a:srgbClr val="0E2268"/>
+                </a:solidFill>
+                <a:latin typeface="Arial"/>
+              </a:rPr>
+              <a:t> = Z)</a:t>
+            </a:r>
+          </a:p>
+        </p:txBody>
+      </p:sp>
+      <p:pic>
+        <p:nvPicPr>
+          <p:cNvPr id="4" name="Picture 3" descr="eq_ratio.png"/>
+          <p:cNvPicPr>
+            <a:picLocks noChangeAspect="1"/>
+          </p:cNvPicPr>
+          <p:nvPr/>
+        </p:nvPicPr>
+        <p:blipFill>
+          <a:blip r:embed="rId2"/>
+          <a:stretch>
+            <a:fillRect/>
+          </a:stretch>
+        </p:blipFill>
+        <p:spPr>
+          <a:xfrm>
+            <a:off x="548640" y="1463040"/>
+            <a:ext cx="7419109" cy="685800"/>
           </a:xfrm>
           <a:prstGeom prst="rect">
             <a:avLst/>
           </a:prstGeom>
-          <a:noFill/>
-        </p:spPr>
-        <p:txBody>
-          <a:bodyPr wrap="square" lIns="36576" rIns="36576" tIns="18288" bIns="18288" anchor="t">
-            <a:spAutoFit/>
-          </a:bodyPr>
-          <a:lstStyle/>
-          <a:p>
-            <a:pPr algn="l">
-              <a:spcAft>
-                <a:spcPts val="200"/>
-              </a:spcAft>
-            </a:pPr>
-            <a:r>
-              <a:rPr sz="1400" b="1">
-                <a:solidFill>
-                  <a:srgbClr val="0E2268"/>
-                </a:solidFill>
-                <a:latin typeface="Arial"/>
-              </a:rPr>
-              <a:t>ENA</a:t>
-            </a:r>
-          </a:p>
-          <a:p>
-            <a:pPr algn="l">
-              <a:spcAft>
-                <a:spcPts val="200"/>
-              </a:spcAft>
-            </a:pPr>
-            <a:r>
-              <a:rPr sz="1300" b="0">
-                <a:solidFill>
-                  <a:srgbClr val="1A1A1A"/>
-                </a:solidFill>
-                <a:latin typeface="Arial"/>
-              </a:rPr>
-              <a:t>output → driver</a:t>
-            </a:r>
-          </a:p>
-          <a:p>
-            <a:pPr algn="l">
-              <a:spcAft>
-                <a:spcPts val="200"/>
-              </a:spcAft>
-            </a:pPr>
-            <a:r>
-              <a:rPr sz="1300" b="0">
-                <a:solidFill>
-                  <a:srgbClr val="1A1A1A"/>
-                </a:solidFill>
-                <a:latin typeface="Arial"/>
-              </a:rPr>
-              <a:t>inputs 1, 2 ← two outputs</a:t>
-            </a:r>
-          </a:p>
-        </p:txBody>
-      </p:sp>
-      <p:sp>
-        <p:nvSpPr>
-          <p:cNvPr id="6" name="Right Arrow 5"/>
+        </p:spPr>
+      </p:pic>
+      <p:sp>
+        <p:nvSpPr>
+          <p:cNvPr id="5" name="Rounded Rectangle 4"/>
           <p:cNvSpPr/>
           <p:nvPr/>
         </p:nvSpPr>
         <p:spPr>
           <a:xfrm>
-            <a:off x="3090672" y="1965960"/>
-            <a:ext cx="228600" cy="365760"/>
-          </a:xfrm>
-          <a:prstGeom prst="rightArrow">
-            <a:avLst/>
-          </a:prstGeom>
-          <a:solidFill>
-            <a:srgbClr val="5A606E"/>
-          </a:solidFill>
-          <a:ln>
-            <a:noFill/>
-          </a:ln>
-          <a:effectLst/>
-        </p:spPr>
-        <p:style>
-          <a:lnRef idx="1">
-            <a:schemeClr val="accent1"/>
-          </a:lnRef>
-          <a:fillRef idx="3">
-            <a:schemeClr val="accent1"/>
-          </a:fillRef>
-          <a:effectRef idx="2">
-            <a:schemeClr val="accent1"/>
-          </a:effectRef>
-          <a:fontRef idx="minor">
-            <a:schemeClr val="lt1"/>
-          </a:fontRef>
-        </p:style>
-        <p:txBody>
-          <a:bodyPr rtlCol="0" anchor="ctr"/>
-          <a:lstStyle/>
-          <a:p>
-            <a:pPr algn="ctr"/>
-          </a:p>
-        </p:txBody>
-      </p:sp>
-      <p:sp>
-        <p:nvSpPr>
-          <p:cNvPr id="7" name="Rounded Rectangle 6"/>
-          <p:cNvSpPr/>
-          <p:nvPr/>
-        </p:nvSpPr>
-        <p:spPr>
-          <a:xfrm>
-            <a:off x="3337560" y="1508760"/>
-            <a:ext cx="2606040" cy="1234440"/>
-          </a:xfrm>
-          <a:prstGeom prst="roundRect">
-            <a:avLst>
-              <a:gd name="adj" fmla="val 6000"/>
-            </a:avLst>
-          </a:prstGeom>
-          <a:solidFill>
-            <a:srgbClr val="F1F3F8"/>
-          </a:solidFill>
-          <a:ln w="15875">
-            <a:solidFill>
-              <a:srgbClr val="D9DCE3"/>
-            </a:solidFill>
-          </a:ln>
-          <a:effectLst/>
-        </p:spPr>
-        <p:style>
-          <a:lnRef idx="1">
-            <a:schemeClr val="accent1"/>
-          </a:lnRef>
-          <a:fillRef idx="3">
-            <a:schemeClr val="accent1"/>
-          </a:fillRef>
-          <a:effectRef idx="2">
-            <a:schemeClr val="accent1"/>
-          </a:effectRef>
-          <a:fontRef idx="minor">
-            <a:schemeClr val="lt1"/>
-          </a:fontRef>
-        </p:style>
-        <p:txBody>
-          <a:bodyPr rtlCol="0" anchor="ctr"/>
-          <a:lstStyle/>
-          <a:p>
-            <a:pPr algn="ctr"/>
-          </a:p>
-        </p:txBody>
-      </p:sp>
-      <p:sp>
-        <p:nvSpPr>
-          <p:cNvPr id="8" name="TextBox 7"/>
-          <p:cNvSpPr txBox="1"/>
-          <p:nvPr/>
-        </p:nvSpPr>
-        <p:spPr>
-          <a:xfrm>
-            <a:off x="3429000" y="1581912"/>
-            <a:ext cx="2423160" cy="1143000"/>
-          </a:xfrm>
-          <a:prstGeom prst="rect">
-            <a:avLst/>
-          </a:prstGeom>
-          <a:noFill/>
-        </p:spPr>
-        <p:txBody>
-          <a:bodyPr wrap="square" lIns="36576" rIns="36576" tIns="18288" bIns="18288" anchor="t">
-            <a:spAutoFit/>
-          </a:bodyPr>
-          <a:lstStyle/>
-          <a:p>
-            <a:pPr algn="l">
-              <a:spcAft>
-                <a:spcPts val="200"/>
-              </a:spcAft>
-            </a:pPr>
-            <a:r>
-              <a:rPr sz="1400" b="1">
-                <a:solidFill>
-                  <a:srgbClr val="0E2268"/>
-                </a:solidFill>
-                <a:latin typeface="Arial"/>
-              </a:rPr>
-              <a:t>SRC</a:t>
-            </a:r>
-          </a:p>
-          <a:p>
-            <a:pPr algn="l">
-              <a:spcAft>
-                <a:spcPts val="200"/>
-              </a:spcAft>
-            </a:pPr>
-            <a:r>
-              <a:rPr sz="1300" b="0">
-                <a:solidFill>
-                  <a:srgbClr val="1A1A1A"/>
-                </a:solidFill>
-                <a:latin typeface="Arial"/>
-              </a:rPr>
-              <a:t>driver, Z</a:t>
-            </a:r>
-            <a:r>
-              <a:rPr sz="1300" b="0" baseline="-25000">
-                <a:solidFill>
-                  <a:srgbClr val="1A1A1A"/>
-                </a:solidFill>
-                <a:latin typeface="Arial"/>
-              </a:rPr>
-              <a:t>s</a:t>
-            </a:r>
-          </a:p>
-        </p:txBody>
-      </p:sp>
-      <p:sp>
-        <p:nvSpPr>
-          <p:cNvPr id="9" name="Right Arrow 8"/>
-          <p:cNvSpPr/>
-          <p:nvPr/>
-        </p:nvSpPr>
-        <p:spPr>
-          <a:xfrm>
-            <a:off x="5971031" y="1965960"/>
-            <a:ext cx="228600" cy="365760"/>
-          </a:xfrm>
-          <a:prstGeom prst="rightArrow">
-            <a:avLst/>
-          </a:prstGeom>
-          <a:solidFill>
-            <a:srgbClr val="5A606E"/>
-          </a:solidFill>
-          <a:ln>
-            <a:noFill/>
-          </a:ln>
-          <a:effectLst/>
-        </p:spPr>
-        <p:style>
-          <a:lnRef idx="1">
-            <a:schemeClr val="accent1"/>
-          </a:lnRef>
-          <a:fillRef idx="3">
-            <a:schemeClr val="accent1"/>
-          </a:fillRef>
-          <a:effectRef idx="2">
-            <a:schemeClr val="accent1"/>
-          </a:effectRef>
-          <a:fontRef idx="minor">
-            <a:schemeClr val="lt1"/>
-          </a:fontRef>
-        </p:style>
-        <p:txBody>
-          <a:bodyPr rtlCol="0" anchor="ctr"/>
-          <a:lstStyle/>
-          <a:p>
-            <a:pPr algn="ctr"/>
-          </a:p>
-        </p:txBody>
-      </p:sp>
-      <p:sp>
-        <p:nvSpPr>
-          <p:cNvPr id="10" name="Rounded Rectangle 9"/>
-          <p:cNvSpPr/>
-          <p:nvPr/>
-        </p:nvSpPr>
-        <p:spPr>
-          <a:xfrm>
-            <a:off x="6217920" y="1508760"/>
-            <a:ext cx="2606040" cy="1234440"/>
-          </a:xfrm>
-          <a:prstGeom prst="roundRect">
-            <a:avLst>
-              <a:gd name="adj" fmla="val 6000"/>
-            </a:avLst>
-          </a:prstGeom>
-          <a:solidFill>
-            <a:srgbClr val="F1F3F8"/>
-          </a:solidFill>
-          <a:ln w="15875">
-            <a:solidFill>
-              <a:srgbClr val="D9DCE3"/>
-            </a:solidFill>
-          </a:ln>
-          <a:effectLst/>
-        </p:spPr>
-        <p:style>
-          <a:lnRef idx="1">
-            <a:schemeClr val="accent1"/>
-          </a:lnRef>
-          <a:fillRef idx="3">
-            <a:schemeClr val="accent1"/>
-          </a:fillRef>
-          <a:effectRef idx="2">
-            <a:schemeClr val="accent1"/>
-          </a:effectRef>
-          <a:fontRef idx="minor">
-            <a:schemeClr val="lt1"/>
-          </a:fontRef>
-        </p:style>
-        <p:txBody>
-          <a:bodyPr rtlCol="0" anchor="ctr"/>
-          <a:lstStyle/>
-          <a:p>
-            <a:pPr algn="ctr"/>
-          </a:p>
-        </p:txBody>
-      </p:sp>
-      <p:sp>
-        <p:nvSpPr>
-          <p:cNvPr id="11" name="TextBox 10"/>
-          <p:cNvSpPr txBox="1"/>
-          <p:nvPr/>
-        </p:nvSpPr>
-        <p:spPr>
-          <a:xfrm>
-            <a:off x="6309359" y="1581912"/>
-            <a:ext cx="2423160" cy="1143000"/>
-          </a:xfrm>
-          <a:prstGeom prst="rect">
-            <a:avLst/>
-          </a:prstGeom>
-          <a:noFill/>
-        </p:spPr>
-        <p:txBody>
-          <a:bodyPr wrap="square" lIns="36576" rIns="36576" tIns="18288" bIns="18288" anchor="t">
-            <a:spAutoFit/>
-          </a:bodyPr>
-          <a:lstStyle/>
-          <a:p>
-            <a:pPr algn="l">
-              <a:spcAft>
-                <a:spcPts val="200"/>
-              </a:spcAft>
-            </a:pPr>
-            <a:r>
-              <a:rPr sz="1400" b="1">
-                <a:solidFill>
-                  <a:srgbClr val="0E2268"/>
-                </a:solidFill>
-                <a:latin typeface="Arial"/>
-              </a:rPr>
-              <a:t>CTL</a:t>
-            </a:r>
-          </a:p>
-          <a:p>
-            <a:pPr algn="l">
-              <a:spcAft>
-                <a:spcPts val="200"/>
-              </a:spcAft>
-            </a:pPr>
-            <a:r>
-              <a:rPr sz="1300" b="0">
-                <a:solidFill>
-                  <a:srgbClr val="1A1A1A"/>
-                </a:solidFill>
-                <a:latin typeface="Arial"/>
-              </a:rPr>
-              <a:t>Coupled TL element</a:t>
-            </a:r>
-          </a:p>
-        </p:txBody>
-      </p:sp>
-      <p:sp>
-        <p:nvSpPr>
-          <p:cNvPr id="12" name="Right Arrow 11"/>
-          <p:cNvSpPr/>
-          <p:nvPr/>
-        </p:nvSpPr>
-        <p:spPr>
-          <a:xfrm>
-            <a:off x="8851392" y="1965960"/>
-            <a:ext cx="228600" cy="365760"/>
-          </a:xfrm>
-          <a:prstGeom prst="rightArrow">
-            <a:avLst/>
-          </a:prstGeom>
-          <a:solidFill>
-            <a:srgbClr val="5A606E"/>
-          </a:solidFill>
-          <a:ln>
-            <a:noFill/>
-          </a:ln>
-          <a:effectLst/>
-        </p:spPr>
-        <p:style>
-          <a:lnRef idx="1">
-            <a:schemeClr val="accent1"/>
-          </a:lnRef>
-          <a:fillRef idx="3">
-            <a:schemeClr val="accent1"/>
-          </a:fillRef>
-          <a:effectRef idx="2">
-            <a:schemeClr val="accent1"/>
-          </a:effectRef>
-          <a:fontRef idx="minor">
-            <a:schemeClr val="lt1"/>
-          </a:fontRef>
-        </p:style>
-        <p:txBody>
-          <a:bodyPr rtlCol="0" anchor="ctr"/>
-          <a:lstStyle/>
-          <a:p>
-            <a:pPr algn="ctr"/>
-          </a:p>
-        </p:txBody>
-      </p:sp>
-      <p:sp>
-        <p:nvSpPr>
-          <p:cNvPr id="13" name="Rounded Rectangle 12"/>
-          <p:cNvSpPr/>
-          <p:nvPr/>
-        </p:nvSpPr>
-        <p:spPr>
-          <a:xfrm>
-            <a:off x="9098280" y="1508760"/>
-            <a:ext cx="2606040" cy="1234440"/>
-          </a:xfrm>
-          <a:prstGeom prst="roundRect">
-            <a:avLst>
-              <a:gd name="adj" fmla="val 6000"/>
-            </a:avLst>
-          </a:prstGeom>
-          <a:solidFill>
-            <a:srgbClr val="F1F3F8"/>
-          </a:solidFill>
-          <a:ln w="15875">
-            <a:solidFill>
-              <a:srgbClr val="D9DCE3"/>
-            </a:solidFill>
-          </a:ln>
-          <a:effectLst/>
-        </p:spPr>
-        <p:style>
-          <a:lnRef idx="1">
-            <a:schemeClr val="accent1"/>
-          </a:lnRef>
-          <a:fillRef idx="3">
-            <a:schemeClr val="accent1"/>
-          </a:fillRef>
-          <a:effectRef idx="2">
-            <a:schemeClr val="accent1"/>
-          </a:effectRef>
-          <a:fontRef idx="minor">
-            <a:schemeClr val="lt1"/>
-          </a:fontRef>
-        </p:style>
-        <p:txBody>
-          <a:bodyPr rtlCol="0" anchor="ctr"/>
-          <a:lstStyle/>
-          <a:p>
-            <a:pPr algn="ctr"/>
-          </a:p>
-        </p:txBody>
-      </p:sp>
-      <p:sp>
-        <p:nvSpPr>
-          <p:cNvPr id="14" name="TextBox 13"/>
-          <p:cNvSpPr txBox="1"/>
-          <p:nvPr/>
-        </p:nvSpPr>
-        <p:spPr>
-          <a:xfrm>
-            <a:off x="9189719" y="1581912"/>
-            <a:ext cx="2423160" cy="1143000"/>
-          </a:xfrm>
-          <a:prstGeom prst="rect">
-            <a:avLst/>
-          </a:prstGeom>
-          <a:noFill/>
-        </p:spPr>
-        <p:txBody>
-          <a:bodyPr wrap="square" lIns="36576" rIns="36576" tIns="18288" bIns="18288" anchor="t">
-            <a:spAutoFit/>
-          </a:bodyPr>
-          <a:lstStyle/>
-          <a:p>
-            <a:pPr algn="l">
-              <a:spcAft>
-                <a:spcPts val="200"/>
-              </a:spcAft>
-            </a:pPr>
-            <a:r>
-              <a:rPr sz="1400" b="1">
-                <a:solidFill>
-                  <a:srgbClr val="0E2268"/>
-                </a:solidFill>
-                <a:latin typeface="Arial"/>
-              </a:rPr>
-              <a:t>LOAD_A2 / B2</a:t>
-            </a:r>
-          </a:p>
-          <a:p>
-            <a:pPr algn="l">
-              <a:spcAft>
-                <a:spcPts val="200"/>
-              </a:spcAft>
-            </a:pPr>
-            <a:r>
-              <a:rPr sz="1300" b="0">
-                <a:solidFill>
-                  <a:srgbClr val="1A1A1A"/>
-                </a:solidFill>
-                <a:latin typeface="Arial"/>
-              </a:rPr>
-              <a:t>terminations R</a:t>
-            </a:r>
-            <a:r>
-              <a:rPr sz="1300" b="0" baseline="-25000">
-                <a:solidFill>
-                  <a:srgbClr val="1A1A1A"/>
-                </a:solidFill>
-                <a:latin typeface="Arial"/>
-              </a:rPr>
-              <a:t>t</a:t>
-            </a:r>
-          </a:p>
-        </p:txBody>
-      </p:sp>
-      <p:sp>
-        <p:nvSpPr>
-          <p:cNvPr id="15" name="Rounded Rectangle 14"/>
-          <p:cNvSpPr/>
-          <p:nvPr/>
-        </p:nvSpPr>
-        <p:spPr>
-          <a:xfrm>
-            <a:off x="457200" y="2971800"/>
-            <a:ext cx="5532120" cy="3337560"/>
+            <a:off x="457200" y="2377440"/>
+            <a:ext cx="3657600" cy="2514600"/>
           </a:xfrm>
           <a:prstGeom prst="roundRect">
             <a:avLst>
@@ -6454,14 +5628,14 @@
       </p:sp>
       <p:sp>
         <p:nvSpPr>
-          <p:cNvPr id="16" name="TextBox 15"/>
+          <p:cNvPr id="6" name="TextBox 5"/>
           <p:cNvSpPr txBox="1"/>
           <p:nvPr/>
         </p:nvSpPr>
         <p:spPr>
           <a:xfrm>
-            <a:off x="594360" y="3044952"/>
-            <a:ext cx="5257800" cy="3227832"/>
+            <a:off x="594360" y="2450592"/>
+            <a:ext cx="3383280" cy="2404872"/>
           </a:xfrm>
           <a:prstGeom prst="rect">
             <a:avLst/>
@@ -6486,7 +5660,7 @@
                 </a:solidFill>
                 <a:latin typeface="Arial"/>
               </a:rPr>
-              <a:t>Why this form</a:t>
+              <a:t>Launch term δ/4 (NEXT-like)</a:t>
             </a:r>
           </a:p>
           <a:p>
@@ -6502,7 +5676,7 @@
                 </a:solidFill>
                 <a:latin typeface="Arial"/>
               </a:rPr>
-              <a:t>LOAD_B1 = Z</a:t>
+              <a:t>The impedance split launches unequal even and odd waves: Z</a:t>
             </a:r>
             <a:r>
               <a:rPr sz="1350" b="0" baseline="-25000">
@@ -6511,6 +5685,42 @@
                 </a:solidFill>
                 <a:latin typeface="Arial"/>
               </a:rPr>
+              <a:t>m</a:t>
+            </a:r>
+            <a:r>
+              <a:rPr sz="1350" b="0">
+                <a:solidFill>
+                  <a:srgbClr val="1A1A1A"/>
+                </a:solidFill>
+                <a:latin typeface="Arial"/>
+              </a:rPr>
+              <a:t>/(Z</a:t>
+            </a:r>
+            <a:r>
+              <a:rPr sz="1350" b="0" baseline="-25000">
+                <a:solidFill>
+                  <a:srgbClr val="1A1A1A"/>
+                </a:solidFill>
+                <a:latin typeface="Arial"/>
+              </a:rPr>
+              <a:t>m</a:t>
+            </a:r>
+            <a:r>
+              <a:rPr sz="1350" b="0">
+                <a:solidFill>
+                  <a:srgbClr val="1A1A1A"/>
+                </a:solidFill>
+                <a:latin typeface="Arial"/>
+              </a:rPr>
+              <a:t>+Z</a:t>
+            </a:r>
+            <a:r>
+              <a:rPr sz="1350" b="0" baseline="-25000">
+                <a:solidFill>
+                  <a:srgbClr val="1A1A1A"/>
+                </a:solidFill>
+                <a:latin typeface="Arial"/>
+              </a:rPr>
               <a:t>s</a:t>
             </a:r>
             <a:r>
@@ -6520,7 +5730,7 @@
                 </a:solidFill>
                 <a:latin typeface="Arial"/>
               </a:rPr>
-              <a:t>: victim's input on its own idle driver.</a:t>
+              <a:t>) differs by δ/4.</a:t>
             </a:r>
           </a:p>
           <a:p>
@@ -6536,7 +5746,7 @@
                 </a:solidFill>
                 <a:latin typeface="Arial"/>
               </a:rPr>
-              <a:t>Compound with scattering-data analysis on: only there are reflections exact (Step 0 result).</a:t>
+              <a:t>Result: a forward wave of relative size δ/4 starts on B at the input and travels with the light.</a:t>
             </a:r>
           </a:p>
           <a:p>
@@ -6552,21 +5762,39 @@
                 </a:solidFill>
                 <a:latin typeface="Arial"/>
               </a:rPr>
-              <a:t>Three rows: an analyser reads two outputs; MOD = modulation A/B, FE = far end, NE = near end.</a:t>
-            </a:r>
-          </a:p>
-        </p:txBody>
-      </p:sp>
-      <p:sp>
-        <p:nvSpPr>
-          <p:cNvPr id="17" name="Rounded Rectangle 16"/>
+              <a:t>Same δ/4 as in NEXT ≈ (δ/4)(1 − t</a:t>
+            </a:r>
+            <a:r>
+              <a:rPr sz="1350" b="0" baseline="30000">
+                <a:solidFill>
+                  <a:srgbClr val="1A1A1A"/>
+                </a:solidFill>
+                <a:latin typeface="Arial"/>
+              </a:rPr>
+              <a:t>2</a:t>
+            </a:r>
+            <a:r>
+              <a:rPr sz="1350" b="0">
+                <a:solidFill>
+                  <a:srgbClr val="1A1A1A"/>
+                </a:solidFill>
+                <a:latin typeface="Arial"/>
+              </a:rPr>
+              <a:t>).</a:t>
+            </a:r>
+          </a:p>
+        </p:txBody>
+      </p:sp>
+      <p:sp>
+        <p:nvSpPr>
+          <p:cNvPr id="7" name="Rounded Rectangle 6"/>
           <p:cNvSpPr/>
           <p:nvPr/>
         </p:nvSpPr>
         <p:spPr>
           <a:xfrm>
-            <a:off x="6199632" y="2971800"/>
-            <a:ext cx="5550408" cy="3337560"/>
+            <a:off x="4270248" y="2377440"/>
+            <a:ext cx="3657600" cy="2514600"/>
           </a:xfrm>
           <a:prstGeom prst="roundRect">
             <a:avLst>
@@ -6605,14 +5833,14 @@
       </p:sp>
       <p:sp>
         <p:nvSpPr>
-          <p:cNvPr id="18" name="TextBox 17"/>
+          <p:cNvPr id="8" name="TextBox 7"/>
           <p:cNvSpPr txBox="1"/>
           <p:nvPr/>
         </p:nvSpPr>
         <p:spPr>
           <a:xfrm>
-            <a:off x="6336792" y="3044952"/>
-            <a:ext cx="5276088" cy="3227832"/>
+            <a:off x="4407408" y="2450592"/>
+            <a:ext cx="3383280" cy="2404872"/>
           </a:xfrm>
           <a:prstGeom prst="rect">
             <a:avLst/>
@@ -6637,7 +5865,7 @@
                 </a:solidFill>
                 <a:latin typeface="Arial"/>
               </a:rPr>
-              <a:t>How it is compared</a:t>
+              <a:t>Accumulated term (FEXT-like)</a:t>
             </a:r>
           </a:p>
           <a:p>
@@ -6653,7 +5881,7 @@
                 </a:solidFill>
                 <a:latin typeface="Arial"/>
               </a:rPr>
-              <a:t>Scale, latency and phase convention measured on the aggressor (A).</a:t>
+              <a:t>Even and odd waves drift apart at Δβ; the light averages the growing voltage on B.</a:t>
             </a:r>
           </a:p>
           <a:p>
@@ -6669,9 +5897,102 @@
                 </a:solidFill>
                 <a:latin typeface="Arial"/>
               </a:rPr>
-              <a:t>The same corrections applied to the victim (B): its error is the coupling error alone.</a:t>
-            </a:r>
-          </a:p>
+              <a:t>Velocity-matched, lossless line: average = half the far-end value.</a:t>
+            </a:r>
+          </a:p>
+        </p:txBody>
+      </p:sp>
+      <p:pic>
+        <p:nvPicPr>
+          <p:cNvPr id="9" name="Picture 8" descr="eq_limit.png"/>
+          <p:cNvPicPr>
+            <a:picLocks noChangeAspect="1"/>
+          </p:cNvPicPr>
+          <p:nvPr/>
+        </p:nvPicPr>
+        <p:blipFill>
+          <a:blip r:embed="rId3"/>
+          <a:stretch>
+            <a:fillRect/>
+          </a:stretch>
+        </p:blipFill>
+        <p:spPr>
+          <a:xfrm>
+            <a:off x="4389120" y="4983480"/>
+            <a:ext cx="3362960" cy="548640"/>
+          </a:xfrm>
+          <a:prstGeom prst="rect">
+            <a:avLst/>
+          </a:prstGeom>
+        </p:spPr>
+      </p:pic>
+      <p:sp>
+        <p:nvSpPr>
+          <p:cNvPr id="10" name="Rounded Rectangle 9"/>
+          <p:cNvSpPr/>
+          <p:nvPr/>
+        </p:nvSpPr>
+        <p:spPr>
+          <a:xfrm>
+            <a:off x="8083296" y="2377440"/>
+            <a:ext cx="3666744" cy="2514600"/>
+          </a:xfrm>
+          <a:prstGeom prst="roundRect">
+            <a:avLst>
+              <a:gd name="adj" fmla="val 6000"/>
+            </a:avLst>
+          </a:prstGeom>
+          <a:solidFill>
+            <a:srgbClr val="F1F3F8"/>
+          </a:solidFill>
+          <a:ln>
+            <a:noFill/>
+          </a:ln>
+          <a:effectLst/>
+        </p:spPr>
+        <p:style>
+          <a:lnRef idx="1">
+            <a:schemeClr val="accent1"/>
+          </a:lnRef>
+          <a:fillRef idx="3">
+            <a:schemeClr val="accent1"/>
+          </a:fillRef>
+          <a:effectRef idx="2">
+            <a:schemeClr val="accent1"/>
+          </a:effectRef>
+          <a:fontRef idx="minor">
+            <a:schemeClr val="lt1"/>
+          </a:fontRef>
+        </p:style>
+        <p:txBody>
+          <a:bodyPr rtlCol="0" anchor="ctr"/>
+          <a:lstStyle/>
+          <a:p>
+            <a:pPr algn="ctr"/>
+          </a:p>
+        </p:txBody>
+      </p:sp>
+      <p:sp>
+        <p:nvSpPr>
+          <p:cNvPr id="11" name="TextBox 10"/>
+          <p:cNvSpPr txBox="1"/>
+          <p:nvPr/>
+        </p:nvSpPr>
+        <p:spPr>
+          <a:xfrm>
+            <a:off x="8220456" y="2450592"/>
+            <a:ext cx="3392424" cy="2404872"/>
+          </a:xfrm>
+          <a:prstGeom prst="rect">
+            <a:avLst/>
+          </a:prstGeom>
+          <a:noFill/>
+        </p:spPr>
+        <p:txBody>
+          <a:bodyPr wrap="square" lIns="36576" rIns="36576" tIns="18288" bIns="18288" anchor="t">
+            <a:spAutoFit/>
+          </a:bodyPr>
+          <a:lstStyle/>
           <a:p>
             <a:pPr algn="l">
               <a:spcAft>
@@ -6679,13 +6000,493 @@
               </a:spcAft>
             </a:pPr>
             <a:r>
+              <a:rPr sz="1500" b="1">
+                <a:solidFill>
+                  <a:srgbClr val="F20013"/>
+                </a:solidFill>
+                <a:latin typeface="Arial"/>
+              </a:rPr>
+              <a:t>Backward waves (NEXT path)</a:t>
+            </a:r>
+          </a:p>
+          <a:p>
+            <a:pPr algn="l">
+              <a:spcAft>
+                <a:spcPts val="300"/>
+              </a:spcAft>
+            </a:pPr>
+            <a:r>
               <a:rPr sz="1350" b="0">
                 <a:solidFill>
                   <a:srgbClr val="1A1A1A"/>
                 </a:solidFill>
                 <a:latin typeface="Arial"/>
               </a:rPr>
-              <a:t>Scale 2.00 = EMF vs incident-wave convention; 341 ps = FIR filter delay.</a:t>
+              <a:t>Travel against the light: their integral is phase-mismatched and suppressed by</a:t>
+            </a:r>
+          </a:p>
+        </p:txBody>
+      </p:sp>
+      <p:pic>
+        <p:nvPicPr>
+          <p:cNvPr id="12" name="Picture 11" descr="eq_back.png"/>
+          <p:cNvPicPr>
+            <a:picLocks noChangeAspect="1"/>
+          </p:cNvPicPr>
+          <p:nvPr/>
+        </p:nvPicPr>
+        <p:blipFill>
+          <a:blip r:embed="rId4"/>
+          <a:stretch>
+            <a:fillRect/>
+          </a:stretch>
+        </p:blipFill>
+        <p:spPr>
+          <a:xfrm>
+            <a:off x="8229600" y="3749039"/>
+            <a:ext cx="2703549" cy="594360"/>
+          </a:xfrm>
+          <a:prstGeom prst="rect">
+            <a:avLst/>
+          </a:prstGeom>
+        </p:spPr>
+      </p:pic>
+      <p:sp>
+        <p:nvSpPr>
+          <p:cNvPr id="13" name="TextBox 12"/>
+          <p:cNvSpPr txBox="1"/>
+          <p:nvPr/>
+        </p:nvSpPr>
+        <p:spPr>
+          <a:xfrm>
+            <a:off x="8183879" y="4434840"/>
+            <a:ext cx="3474720" cy="457200"/>
+          </a:xfrm>
+          <a:prstGeom prst="rect">
+            <a:avLst/>
+          </a:prstGeom>
+          <a:noFill/>
+        </p:spPr>
+        <p:txBody>
+          <a:bodyPr wrap="square" lIns="36576" rIns="36576" tIns="18288" bIns="18288" anchor="t">
+            <a:spAutoFit/>
+          </a:bodyPr>
+          <a:lstStyle/>
+          <a:p>
+            <a:pPr algn="l">
+              <a:spcAft>
+                <a:spcPts val="400"/>
+              </a:spcAft>
+            </a:pPr>
+            <a:r>
+              <a:rPr sz="1200" b="0">
+                <a:solidFill>
+                  <a:srgbClr val="5A606E"/>
+                </a:solidFill>
+                <a:latin typeface="Arial"/>
+              </a:rPr>
+              <a:t>−22 / −31 / −37 dB at 10 / 30 / 60 GHz (14 mm)</a:t>
+            </a:r>
+          </a:p>
+        </p:txBody>
+      </p:sp>
+      <p:graphicFrame>
+        <p:nvGraphicFramePr>
+          <p:cNvPr id="14" name="Table 13"/>
+          <p:cNvGraphicFramePr>
+            <a:graphicFrameLocks noGrp="1"/>
+          </p:cNvGraphicFramePr>
+          <p:nvPr/>
+        </p:nvGraphicFramePr>
+        <p:xfrm>
+          <a:off x="457200" y="5623560"/>
+          <a:ext cx="7498080" cy="877824"/>
+        </p:xfrm>
+        <a:graphic>
+          <a:graphicData uri="http://schemas.openxmlformats.org/drawingml/2006/table">
+            <a:tbl>
+              <a:tblPr firstRow="0" bandRow="0"/>
+              <a:tblGrid>
+                <a:gridCol w="2999232"/>
+                <a:gridCol w="1499616"/>
+                <a:gridCol w="1499616"/>
+                <a:gridCol w="1499616"/>
+              </a:tblGrid>
+              <a:tr h="292608">
+                <a:tc>
+                  <a:txBody>
+                    <a:bodyPr wrap="square"/>
+                    <a:lstStyle/>
+                    <a:p>
+                      <a:pPr algn="l"/>
+                      <a:r>
+                        <a:rPr sz="1200" b="1">
+                          <a:solidFill>
+                            <a:srgbClr val="FFFFFF"/>
+                          </a:solidFill>
+                          <a:latin typeface="Arial"/>
+                        </a:rPr>
+                        <a:t>14 mm, δ = 0.61 %</a:t>
+                      </a:r>
+                    </a:p>
+                  </a:txBody>
+                  <a:tcPr marL="54864" marR="54864" anchor="ctr">
+                    <a:solidFill>
+                      <a:srgbClr val="0E2268"/>
+                    </a:solidFill>
+                  </a:tcPr>
+                </a:tc>
+                <a:tc>
+                  <a:txBody>
+                    <a:bodyPr wrap="square"/>
+                    <a:lstStyle/>
+                    <a:p>
+                      <a:pPr algn="ctr"/>
+                      <a:r>
+                        <a:rPr sz="1200" b="1">
+                          <a:solidFill>
+                            <a:srgbClr val="FFFFFF"/>
+                          </a:solidFill>
+                          <a:latin typeface="Arial"/>
+                        </a:rPr>
+                        <a:t>10 GHz</a:t>
+                      </a:r>
+                    </a:p>
+                  </a:txBody>
+                  <a:tcPr marL="54864" marR="54864" anchor="ctr">
+                    <a:solidFill>
+                      <a:srgbClr val="0E2268"/>
+                    </a:solidFill>
+                  </a:tcPr>
+                </a:tc>
+                <a:tc>
+                  <a:txBody>
+                    <a:bodyPr wrap="square"/>
+                    <a:lstStyle/>
+                    <a:p>
+                      <a:pPr algn="ctr"/>
+                      <a:r>
+                        <a:rPr sz="1200" b="1">
+                          <a:solidFill>
+                            <a:srgbClr val="FFFFFF"/>
+                          </a:solidFill>
+                          <a:latin typeface="Arial"/>
+                        </a:rPr>
+                        <a:t>30 GHz</a:t>
+                      </a:r>
+                    </a:p>
+                  </a:txBody>
+                  <a:tcPr marL="54864" marR="54864" anchor="ctr">
+                    <a:solidFill>
+                      <a:srgbClr val="0E2268"/>
+                    </a:solidFill>
+                  </a:tcPr>
+                </a:tc>
+                <a:tc>
+                  <a:txBody>
+                    <a:bodyPr wrap="square"/>
+                    <a:lstStyle/>
+                    <a:p>
+                      <a:pPr algn="ctr"/>
+                      <a:r>
+                        <a:rPr sz="1200" b="1">
+                          <a:solidFill>
+                            <a:srgbClr val="FFFFFF"/>
+                          </a:solidFill>
+                          <a:latin typeface="Arial"/>
+                        </a:rPr>
+                        <a:t>60 GHz</a:t>
+                      </a:r>
+                    </a:p>
+                  </a:txBody>
+                  <a:tcPr marL="54864" marR="54864" anchor="ctr">
+                    <a:solidFill>
+                      <a:srgbClr val="0E2268"/>
+                    </a:solidFill>
+                  </a:tcPr>
+                </a:tc>
+              </a:tr>
+              <a:tr h="292608">
+                <a:tc>
+                  <a:txBody>
+                    <a:bodyPr wrap="square"/>
+                    <a:lstStyle/>
+                    <a:p>
+                      <a:pPr algn="l"/>
+                      <a:r>
+                        <a:rPr sz="1200" b="1">
+                          <a:solidFill>
+                            <a:srgbClr val="1A1A1A"/>
+                          </a:solidFill>
+                          <a:latin typeface="Arial"/>
+                        </a:rPr>
+                        <a:t>Exact twin (Z</a:t>
+                      </a:r>
+                      <a:r>
+                        <a:rPr sz="1200" b="1" baseline="-25000">
+                          <a:solidFill>
+                            <a:srgbClr val="1A1A1A"/>
+                          </a:solidFill>
+                          <a:latin typeface="Arial"/>
+                        </a:rPr>
+                        <a:t>s</a:t>
+                      </a:r>
+                      <a:r>
+                        <a:rPr sz="1200" b="1">
+                          <a:solidFill>
+                            <a:srgbClr val="1A1A1A"/>
+                          </a:solidFill>
+                          <a:latin typeface="Arial"/>
+                        </a:rPr>
+                        <a:t> = R</a:t>
+                      </a:r>
+                      <a:r>
+                        <a:rPr sz="1200" b="1" baseline="-25000">
+                          <a:solidFill>
+                            <a:srgbClr val="1A1A1A"/>
+                          </a:solidFill>
+                          <a:latin typeface="Arial"/>
+                        </a:rPr>
+                        <a:t>t</a:t>
+                      </a:r>
+                      <a:r>
+                        <a:rPr sz="1200" b="1">
+                          <a:solidFill>
+                            <a:srgbClr val="1A1A1A"/>
+                          </a:solidFill>
+                          <a:latin typeface="Arial"/>
+                        </a:rPr>
+                        <a:t> = Z)</a:t>
+                      </a:r>
+                    </a:p>
+                  </a:txBody>
+                  <a:tcPr marL="54864" marR="54864" anchor="ctr">
+                    <a:solidFill>
+                      <a:srgbClr val="F6F7FA"/>
+                    </a:solidFill>
+                  </a:tcPr>
+                </a:tc>
+                <a:tc>
+                  <a:txBody>
+                    <a:bodyPr wrap="square"/>
+                    <a:lstStyle/>
+                    <a:p>
+                      <a:pPr algn="ctr"/>
+                      <a:r>
+                        <a:rPr sz="1200" b="0">
+                          <a:solidFill>
+                            <a:srgbClr val="1A1A1A"/>
+                          </a:solidFill>
+                          <a:latin typeface="Arial"/>
+                        </a:rPr>
+                        <a:t>−53.7 dB</a:t>
+                      </a:r>
+                    </a:p>
+                  </a:txBody>
+                  <a:tcPr marL="54864" marR="54864" anchor="ctr">
+                    <a:solidFill>
+                      <a:srgbClr val="F6F7FA"/>
+                    </a:solidFill>
+                  </a:tcPr>
+                </a:tc>
+                <a:tc>
+                  <a:txBody>
+                    <a:bodyPr wrap="square"/>
+                    <a:lstStyle/>
+                    <a:p>
+                      <a:pPr algn="ctr"/>
+                      <a:r>
+                        <a:rPr sz="1200" b="0">
+                          <a:solidFill>
+                            <a:srgbClr val="1A1A1A"/>
+                          </a:solidFill>
+                          <a:latin typeface="Arial"/>
+                        </a:rPr>
+                        <a:t>−46.3 dB</a:t>
+                      </a:r>
+                    </a:p>
+                  </a:txBody>
+                  <a:tcPr marL="54864" marR="54864" anchor="ctr">
+                    <a:solidFill>
+                      <a:srgbClr val="F6F7FA"/>
+                    </a:solidFill>
+                  </a:tcPr>
+                </a:tc>
+                <a:tc>
+                  <a:txBody>
+                    <a:bodyPr wrap="square"/>
+                    <a:lstStyle/>
+                    <a:p>
+                      <a:pPr algn="ctr"/>
+                      <a:r>
+                        <a:rPr sz="1200" b="0">
+                          <a:solidFill>
+                            <a:srgbClr val="1A1A1A"/>
+                          </a:solidFill>
+                          <a:latin typeface="Arial"/>
+                        </a:rPr>
+                        <a:t>−36.3 dB</a:t>
+                      </a:r>
+                    </a:p>
+                  </a:txBody>
+                  <a:tcPr marL="54864" marR="54864" anchor="ctr">
+                    <a:solidFill>
+                      <a:srgbClr val="F6F7FA"/>
+                    </a:solidFill>
+                  </a:tcPr>
+                </a:tc>
+              </a:tr>
+              <a:tr h="292608">
+                <a:tc>
+                  <a:txBody>
+                    <a:bodyPr wrap="square"/>
+                    <a:lstStyle/>
+                    <a:p>
+                      <a:pPr algn="l"/>
+                      <a:r>
+                        <a:rPr sz="1200" b="1">
+                          <a:solidFill>
+                            <a:srgbClr val="1A1A1A"/>
+                          </a:solidFill>
+                          <a:latin typeface="Arial"/>
+                        </a:rPr>
+                        <a:t>Formula above</a:t>
+                      </a:r>
+                    </a:p>
+                  </a:txBody>
+                  <a:tcPr marL="54864" marR="54864" anchor="ctr">
+                    <a:solidFill>
+                      <a:srgbClr val="FFFFFF"/>
+                    </a:solidFill>
+                  </a:tcPr>
+                </a:tc>
+                <a:tc>
+                  <a:txBody>
+                    <a:bodyPr wrap="square"/>
+                    <a:lstStyle/>
+                    <a:p>
+                      <a:pPr algn="ctr"/>
+                      <a:r>
+                        <a:rPr sz="1200" b="0">
+                          <a:solidFill>
+                            <a:srgbClr val="1A1A1A"/>
+                          </a:solidFill>
+                          <a:latin typeface="Arial"/>
+                        </a:rPr>
+                        <a:t>−53.6 dB</a:t>
+                      </a:r>
+                    </a:p>
+                  </a:txBody>
+                  <a:tcPr marL="54864" marR="54864" anchor="ctr">
+                    <a:solidFill>
+                      <a:srgbClr val="FFFFFF"/>
+                    </a:solidFill>
+                  </a:tcPr>
+                </a:tc>
+                <a:tc>
+                  <a:txBody>
+                    <a:bodyPr wrap="square"/>
+                    <a:lstStyle/>
+                    <a:p>
+                      <a:pPr algn="ctr"/>
+                      <a:r>
+                        <a:rPr sz="1200" b="0">
+                          <a:solidFill>
+                            <a:srgbClr val="1A1A1A"/>
+                          </a:solidFill>
+                          <a:latin typeface="Arial"/>
+                        </a:rPr>
+                        <a:t>−46.2 dB</a:t>
+                      </a:r>
+                    </a:p>
+                  </a:txBody>
+                  <a:tcPr marL="54864" marR="54864" anchor="ctr">
+                    <a:solidFill>
+                      <a:srgbClr val="FFFFFF"/>
+                    </a:solidFill>
+                  </a:tcPr>
+                </a:tc>
+                <a:tc>
+                  <a:txBody>
+                    <a:bodyPr wrap="square"/>
+                    <a:lstStyle/>
+                    <a:p>
+                      <a:pPr algn="ctr"/>
+                      <a:r>
+                        <a:rPr sz="1200" b="0">
+                          <a:solidFill>
+                            <a:srgbClr val="1A1A1A"/>
+                          </a:solidFill>
+                          <a:latin typeface="Arial"/>
+                        </a:rPr>
+                        <a:t>−36.3 dB</a:t>
+                      </a:r>
+                    </a:p>
+                  </a:txBody>
+                  <a:tcPr marL="54864" marR="54864" anchor="ctr">
+                    <a:solidFill>
+                      <a:srgbClr val="FFFFFF"/>
+                    </a:solidFill>
+                  </a:tcPr>
+                </a:tc>
+              </a:tr>
+            </a:tbl>
+          </a:graphicData>
+        </a:graphic>
+      </p:graphicFrame>
+      <p:sp>
+        <p:nvSpPr>
+          <p:cNvPr id="15" name="TextBox 14"/>
+          <p:cNvSpPr txBox="1"/>
+          <p:nvPr/>
+        </p:nvSpPr>
+        <p:spPr>
+          <a:xfrm>
+            <a:off x="8183879" y="5623560"/>
+            <a:ext cx="3566160" cy="868680"/>
+          </a:xfrm>
+          <a:prstGeom prst="rect">
+            <a:avLst/>
+          </a:prstGeom>
+          <a:noFill/>
+        </p:spPr>
+        <p:txBody>
+          <a:bodyPr wrap="square" lIns="36576" rIns="36576" tIns="18288" bIns="18288" anchor="t">
+            <a:spAutoFit/>
+          </a:bodyPr>
+          <a:lstStyle/>
+          <a:p>
+            <a:pPr algn="l">
+              <a:spcAft>
+                <a:spcPts val="400"/>
+              </a:spcAft>
+            </a:pPr>
+            <a:r>
+              <a:rPr sz="1200" b="0">
+                <a:solidFill>
+                  <a:srgbClr val="5A606E"/>
+                </a:solidFill>
+                <a:latin typeface="Arial"/>
+              </a:rPr>
+              <a:t>Below ~5 GHz, (β + β</a:t>
+            </a:r>
+            <a:r>
+              <a:rPr sz="1200" b="0" baseline="-25000">
+                <a:solidFill>
+                  <a:srgbClr val="5A606E"/>
+                </a:solidFill>
+                <a:latin typeface="Arial"/>
+              </a:rPr>
+              <a:t>o</a:t>
+            </a:r>
+            <a:r>
+              <a:rPr sz="1200" b="0">
+                <a:solidFill>
+                  <a:srgbClr val="5A606E"/>
+                </a:solidFill>
+                <a:latin typeface="Arial"/>
+              </a:rPr>
+              <a:t>)L is small and the backward terms add 1–3 dB.</a:t>
             </a:r>
           </a:p>
         </p:txBody>
@@ -6742,7 +6543,7 @@
                 </a:solidFill>
                 <a:latin typeface="Arial"/>
               </a:rPr>
-              <a:t>Full MZM cascade in crosstalk mode</a:t>
+              <a:t>INTERCONNECT: the "Coupled TL" scripted element</a:t>
             </a:r>
           </a:p>
         </p:txBody>
@@ -6781,7 +6582,7 @@
                 </a:solidFill>
                 <a:latin typeface="Arial"/>
               </a:rPr>
-              <a:t>Two modulators on one coupled electrode; built and dry-run, first INTERCONNECT run pending</a:t>
+              <a:t>The single-line TL element, computed twice (even, odd) and recombined</a:t>
             </a:r>
           </a:p>
         </p:txBody>
@@ -6795,7 +6596,7 @@
         <p:spPr>
           <a:xfrm>
             <a:off x="457200" y="1463040"/>
-            <a:ext cx="2194560" cy="1005840"/>
+            <a:ext cx="3291840" cy="1828800"/>
           </a:xfrm>
           <a:prstGeom prst="roundRect">
             <a:avLst>
@@ -6843,7 +6644,7 @@
         <p:spPr>
           <a:xfrm>
             <a:off x="548640" y="1536192"/>
-            <a:ext cx="2011679" cy="914400"/>
+            <a:ext cx="3108960" cy="1737360"/>
           </a:xfrm>
           <a:prstGeom prst="rect">
             <a:avLst/>
@@ -6868,55 +6669,853 @@
                 </a:solidFill>
                 <a:latin typeface="Arial"/>
               </a:rPr>
-              <a:t>Driver A (Z</a:t>
-            </a:r>
-            <a:r>
-              <a:rPr sz="1400" b="1" baseline="-25000">
+              <a:t>TL line element (existing)</a:t>
+            </a:r>
+          </a:p>
+          <a:p>
+            <a:pPr algn="l">
+              <a:spcAft>
+                <a:spcPts val="200"/>
+              </a:spcAft>
+            </a:pPr>
+            <a:r>
+              <a:rPr sz="1300" b="0">
+                <a:solidFill>
+                  <a:srgbClr val="1A1A1A"/>
+                </a:solidFill>
+                <a:latin typeface="Arial"/>
+              </a:rPr>
+              <a:t>1 table: f, loss, n, Re Z, Im Z</a:t>
+            </a:r>
+          </a:p>
+          <a:p>
+            <a:pPr algn="l">
+              <a:spcAft>
+                <a:spcPts val="200"/>
+              </a:spcAft>
+            </a:pPr>
+            <a:r>
+              <a:rPr sz="1300" b="0">
+                <a:solidFill>
+                  <a:srgbClr val="1A1A1A"/>
+                </a:solidFill>
+                <a:latin typeface="Arial"/>
+              </a:rPr>
+              <a:t>2 ports + modulation output</a:t>
+            </a:r>
+          </a:p>
+          <a:p>
+            <a:pPr algn="l">
+              <a:spcAft>
+                <a:spcPts val="200"/>
+              </a:spcAft>
+            </a:pPr>
+            <a:r>
+              <a:rPr sz="1300" b="0">
+                <a:solidFill>
+                  <a:srgbClr val="1A1A1A"/>
+                </a:solidFill>
+                <a:latin typeface="Arial"/>
+              </a:rPr>
+              <a:t>exact V(z) integral, no slicing</a:t>
+            </a:r>
+          </a:p>
+        </p:txBody>
+      </p:sp>
+      <p:sp>
+        <p:nvSpPr>
+          <p:cNvPr id="6" name="Right Arrow 5"/>
+          <p:cNvSpPr/>
+          <p:nvPr/>
+        </p:nvSpPr>
+        <p:spPr>
+          <a:xfrm>
+            <a:off x="3886200" y="2194560"/>
+            <a:ext cx="731520" cy="365760"/>
+          </a:xfrm>
+          <a:prstGeom prst="rightArrow">
+            <a:avLst/>
+          </a:prstGeom>
+          <a:solidFill>
+            <a:srgbClr val="5A606E"/>
+          </a:solidFill>
+          <a:ln>
+            <a:noFill/>
+          </a:ln>
+          <a:effectLst/>
+        </p:spPr>
+        <p:style>
+          <a:lnRef idx="1">
+            <a:schemeClr val="accent1"/>
+          </a:lnRef>
+          <a:fillRef idx="3">
+            <a:schemeClr val="accent1"/>
+          </a:fillRef>
+          <a:effectRef idx="2">
+            <a:schemeClr val="accent1"/>
+          </a:effectRef>
+          <a:fontRef idx="minor">
+            <a:schemeClr val="lt1"/>
+          </a:fontRef>
+        </p:style>
+        <p:txBody>
+          <a:bodyPr rtlCol="0" anchor="ctr"/>
+          <a:lstStyle/>
+          <a:p>
+            <a:pPr algn="ctr"/>
+          </a:p>
+        </p:txBody>
+      </p:sp>
+      <p:sp>
+        <p:nvSpPr>
+          <p:cNvPr id="7" name="Rounded Rectangle 6"/>
+          <p:cNvSpPr/>
+          <p:nvPr/>
+        </p:nvSpPr>
+        <p:spPr>
+          <a:xfrm>
+            <a:off x="4754880" y="1463040"/>
+            <a:ext cx="3291840" cy="1828800"/>
+          </a:xfrm>
+          <a:prstGeom prst="roundRect">
+            <a:avLst>
+              <a:gd name="adj" fmla="val 6000"/>
+            </a:avLst>
+          </a:prstGeom>
+          <a:solidFill>
+            <a:srgbClr val="FDECEE"/>
+          </a:solidFill>
+          <a:ln w="15875">
+            <a:solidFill>
+              <a:srgbClr val="D9DCE3"/>
+            </a:solidFill>
+          </a:ln>
+          <a:effectLst/>
+        </p:spPr>
+        <p:style>
+          <a:lnRef idx="1">
+            <a:schemeClr val="accent1"/>
+          </a:lnRef>
+          <a:fillRef idx="3">
+            <a:schemeClr val="accent1"/>
+          </a:fillRef>
+          <a:effectRef idx="2">
+            <a:schemeClr val="accent1"/>
+          </a:effectRef>
+          <a:fontRef idx="minor">
+            <a:schemeClr val="lt1"/>
+          </a:fontRef>
+        </p:style>
+        <p:txBody>
+          <a:bodyPr rtlCol="0" anchor="ctr"/>
+          <a:lstStyle/>
+          <a:p>
+            <a:pPr algn="ctr"/>
+          </a:p>
+        </p:txBody>
+      </p:sp>
+      <p:sp>
+        <p:nvSpPr>
+          <p:cNvPr id="8" name="TextBox 7"/>
+          <p:cNvSpPr txBox="1"/>
+          <p:nvPr/>
+        </p:nvSpPr>
+        <p:spPr>
+          <a:xfrm>
+            <a:off x="4846320" y="1536192"/>
+            <a:ext cx="3108960" cy="1737360"/>
+          </a:xfrm>
+          <a:prstGeom prst="rect">
+            <a:avLst/>
+          </a:prstGeom>
+          <a:noFill/>
+        </p:spPr>
+        <p:txBody>
+          <a:bodyPr wrap="square" lIns="36576" rIns="36576" tIns="18288" bIns="18288" anchor="t">
+            <a:spAutoFit/>
+          </a:bodyPr>
+          <a:lstStyle/>
+          <a:p>
+            <a:pPr algn="l">
+              <a:spcAft>
+                <a:spcPts val="200"/>
+              </a:spcAft>
+            </a:pPr>
+            <a:r>
+              <a:rPr sz="1400" b="1">
+                <a:solidFill>
+                  <a:srgbClr val="F20013"/>
+                </a:solidFill>
+                <a:latin typeface="Arial"/>
+              </a:rPr>
+              <a:t>Coupled TL element (new)</a:t>
+            </a:r>
+          </a:p>
+          <a:p>
+            <a:pPr algn="l">
+              <a:spcAft>
+                <a:spcPts val="200"/>
+              </a:spcAft>
+            </a:pPr>
+            <a:r>
+              <a:rPr sz="1300" b="0">
+                <a:solidFill>
+                  <a:srgbClr val="1A1A1A"/>
+                </a:solidFill>
+                <a:latin typeface="Arial"/>
+              </a:rPr>
+              <a:t>2 tables: coupled_even/odd.txt</a:t>
+            </a:r>
+          </a:p>
+          <a:p>
+            <a:pPr algn="l">
+              <a:spcAft>
+                <a:spcPts val="200"/>
+              </a:spcAft>
+            </a:pPr>
+            <a:r>
+              <a:rPr sz="1300" b="0">
+                <a:solidFill>
+                  <a:srgbClr val="1A1A1A"/>
+                </a:solidFill>
+                <a:latin typeface="Arial"/>
+              </a:rPr>
+              <a:t>ports A1, A2, B1, B2</a:t>
+            </a:r>
+          </a:p>
+          <a:p>
+            <a:pPr algn="l">
+              <a:spcAft>
+                <a:spcPts val="200"/>
+              </a:spcAft>
+            </a:pPr>
+            <a:r>
+              <a:rPr sz="1300" b="0">
+                <a:solidFill>
+                  <a:srgbClr val="1A1A1A"/>
+                </a:solidFill>
+                <a:latin typeface="Arial"/>
+              </a:rPr>
+              <a:t>modulation A, B (+ 2 A, 2 B), far/near end</a:t>
+            </a:r>
+          </a:p>
+        </p:txBody>
+      </p:sp>
+      <p:sp>
+        <p:nvSpPr>
+          <p:cNvPr id="9" name="Rounded Rectangle 8"/>
+          <p:cNvSpPr/>
+          <p:nvPr/>
+        </p:nvSpPr>
+        <p:spPr>
+          <a:xfrm>
+            <a:off x="8229600" y="1463040"/>
+            <a:ext cx="3520440" cy="1828800"/>
+          </a:xfrm>
+          <a:prstGeom prst="roundRect">
+            <a:avLst>
+              <a:gd name="adj" fmla="val 6000"/>
+            </a:avLst>
+          </a:prstGeom>
+          <a:solidFill>
+            <a:srgbClr val="F1F3F8"/>
+          </a:solidFill>
+          <a:ln>
+            <a:noFill/>
+          </a:ln>
+          <a:effectLst/>
+        </p:spPr>
+        <p:style>
+          <a:lnRef idx="1">
+            <a:schemeClr val="accent1"/>
+          </a:lnRef>
+          <a:fillRef idx="3">
+            <a:schemeClr val="accent1"/>
+          </a:fillRef>
+          <a:effectRef idx="2">
+            <a:schemeClr val="accent1"/>
+          </a:effectRef>
+          <a:fontRef idx="minor">
+            <a:schemeClr val="lt1"/>
+          </a:fontRef>
+        </p:style>
+        <p:txBody>
+          <a:bodyPr rtlCol="0" anchor="ctr"/>
+          <a:lstStyle/>
+          <a:p>
+            <a:pPr algn="ctr"/>
+          </a:p>
+        </p:txBody>
+      </p:sp>
+      <p:sp>
+        <p:nvSpPr>
+          <p:cNvPr id="10" name="TextBox 9"/>
+          <p:cNvSpPr txBox="1"/>
+          <p:nvPr/>
+        </p:nvSpPr>
+        <p:spPr>
+          <a:xfrm>
+            <a:off x="8366760" y="1536192"/>
+            <a:ext cx="3246120" cy="1719072"/>
+          </a:xfrm>
+          <a:prstGeom prst="rect">
+            <a:avLst/>
+          </a:prstGeom>
+          <a:noFill/>
+        </p:spPr>
+        <p:txBody>
+          <a:bodyPr wrap="square" lIns="36576" rIns="36576" tIns="18288" bIns="18288" anchor="t">
+            <a:spAutoFit/>
+          </a:bodyPr>
+          <a:lstStyle/>
+          <a:p>
+            <a:pPr algn="l">
+              <a:spcAft>
+                <a:spcPts val="300"/>
+              </a:spcAft>
+            </a:pPr>
+            <a:r>
+              <a:rPr sz="1500" b="1">
                 <a:solidFill>
                   <a:srgbClr val="0E2268"/>
                 </a:solidFill>
                 <a:latin typeface="Arial"/>
               </a:rPr>
-              <a:t>s</a:t>
-            </a:r>
-            <a:r>
-              <a:rPr sz="1400" b="1">
+              <a:t>Recombination</a:t>
+            </a:r>
+          </a:p>
+          <a:p>
+            <a:pPr algn="l">
+              <a:spcAft>
+                <a:spcPts val="300"/>
+              </a:spcAft>
+            </a:pPr>
+            <a:r>
+              <a:rPr sz="1350" b="0">
+                <a:solidFill>
+                  <a:srgbClr val="1A1A1A"/>
+                </a:solidFill>
+                <a:latin typeface="Arial"/>
+              </a:rPr>
+              <a:t>S own line = ½(S</a:t>
+            </a:r>
+            <a:r>
+              <a:rPr sz="1350" b="0" baseline="30000">
+                <a:solidFill>
+                  <a:srgbClr val="1A1A1A"/>
+                </a:solidFill>
+                <a:latin typeface="Arial"/>
+              </a:rPr>
+              <a:t>e</a:t>
+            </a:r>
+            <a:r>
+              <a:rPr sz="1350" b="0">
+                <a:solidFill>
+                  <a:srgbClr val="1A1A1A"/>
+                </a:solidFill>
+                <a:latin typeface="Arial"/>
+              </a:rPr>
+              <a:t> + S</a:t>
+            </a:r>
+            <a:r>
+              <a:rPr sz="1350" b="0" baseline="30000">
+                <a:solidFill>
+                  <a:srgbClr val="1A1A1A"/>
+                </a:solidFill>
+                <a:latin typeface="Arial"/>
+              </a:rPr>
+              <a:t>o</a:t>
+            </a:r>
+            <a:r>
+              <a:rPr sz="1350" b="0">
+                <a:solidFill>
+                  <a:srgbClr val="1A1A1A"/>
+                </a:solidFill>
+                <a:latin typeface="Arial"/>
+              </a:rPr>
+              <a:t>)</a:t>
+            </a:r>
+          </a:p>
+          <a:p>
+            <a:pPr algn="l">
+              <a:spcAft>
+                <a:spcPts val="300"/>
+              </a:spcAft>
+            </a:pPr>
+            <a:r>
+              <a:rPr sz="1350" b="0">
+                <a:solidFill>
+                  <a:srgbClr val="1A1A1A"/>
+                </a:solidFill>
+                <a:latin typeface="Arial"/>
+              </a:rPr>
+              <a:t>S other line = ½(S</a:t>
+            </a:r>
+            <a:r>
+              <a:rPr sz="1350" b="0" baseline="30000">
+                <a:solidFill>
+                  <a:srgbClr val="1A1A1A"/>
+                </a:solidFill>
+                <a:latin typeface="Arial"/>
+              </a:rPr>
+              <a:t>e</a:t>
+            </a:r>
+            <a:r>
+              <a:rPr sz="1350" b="0">
+                <a:solidFill>
+                  <a:srgbClr val="1A1A1A"/>
+                </a:solidFill>
+                <a:latin typeface="Arial"/>
+              </a:rPr>
+              <a:t> − S</a:t>
+            </a:r>
+            <a:r>
+              <a:rPr sz="1350" b="0" baseline="30000">
+                <a:solidFill>
+                  <a:srgbClr val="1A1A1A"/>
+                </a:solidFill>
+                <a:latin typeface="Arial"/>
+              </a:rPr>
+              <a:t>o</a:t>
+            </a:r>
+            <a:r>
+              <a:rPr sz="1350" b="0">
+                <a:solidFill>
+                  <a:srgbClr val="1A1A1A"/>
+                </a:solidFill>
+                <a:latin typeface="Arial"/>
+              </a:rPr>
+              <a:t>)</a:t>
+            </a:r>
+          </a:p>
+          <a:p>
+            <a:pPr algn="l">
+              <a:spcAft>
+                <a:spcPts val="300"/>
+              </a:spcAft>
+            </a:pPr>
+            <a:r>
+              <a:rPr sz="1350" b="0">
+                <a:solidFill>
+                  <a:srgbClr val="1A1A1A"/>
+                </a:solidFill>
+                <a:latin typeface="Arial"/>
+              </a:rPr>
+              <a:t>same for the modulation outputs</a:t>
+            </a:r>
+          </a:p>
+        </p:txBody>
+      </p:sp>
+      <p:sp>
+        <p:nvSpPr>
+          <p:cNvPr id="11" name="Rounded Rectangle 10"/>
+          <p:cNvSpPr/>
+          <p:nvPr/>
+        </p:nvSpPr>
+        <p:spPr>
+          <a:xfrm>
+            <a:off x="457200" y="3520440"/>
+            <a:ext cx="5532120" cy="2788920"/>
+          </a:xfrm>
+          <a:prstGeom prst="roundRect">
+            <a:avLst>
+              <a:gd name="adj" fmla="val 6000"/>
+            </a:avLst>
+          </a:prstGeom>
+          <a:solidFill>
+            <a:srgbClr val="F1F3F8"/>
+          </a:solidFill>
+          <a:ln>
+            <a:noFill/>
+          </a:ln>
+          <a:effectLst/>
+        </p:spPr>
+        <p:style>
+          <a:lnRef idx="1">
+            <a:schemeClr val="accent1"/>
+          </a:lnRef>
+          <a:fillRef idx="3">
+            <a:schemeClr val="accent1"/>
+          </a:fillRef>
+          <a:effectRef idx="2">
+            <a:schemeClr val="accent1"/>
+          </a:effectRef>
+          <a:fontRef idx="minor">
+            <a:schemeClr val="lt1"/>
+          </a:fontRef>
+        </p:style>
+        <p:txBody>
+          <a:bodyPr rtlCol="0" anchor="ctr"/>
+          <a:lstStyle/>
+          <a:p>
+            <a:pPr algn="ctr"/>
+          </a:p>
+        </p:txBody>
+      </p:sp>
+      <p:sp>
+        <p:nvSpPr>
+          <p:cNvPr id="12" name="TextBox 11"/>
+          <p:cNvSpPr txBox="1"/>
+          <p:nvPr/>
+        </p:nvSpPr>
+        <p:spPr>
+          <a:xfrm>
+            <a:off x="594360" y="3593592"/>
+            <a:ext cx="5257800" cy="2679191"/>
+          </a:xfrm>
+          <a:prstGeom prst="rect">
+            <a:avLst/>
+          </a:prstGeom>
+          <a:noFill/>
+        </p:spPr>
+        <p:txBody>
+          <a:bodyPr wrap="square" lIns="36576" rIns="36576" tIns="18288" bIns="18288" anchor="t">
+            <a:spAutoFit/>
+          </a:bodyPr>
+          <a:lstStyle/>
+          <a:p>
+            <a:pPr algn="l">
+              <a:spcAft>
+                <a:spcPts val="300"/>
+              </a:spcAft>
+            </a:pPr>
+            <a:r>
+              <a:rPr sz="1500" b="1">
                 <a:solidFill>
                   <a:srgbClr val="0E2268"/>
                 </a:solidFill>
                 <a:latin typeface="Arial"/>
               </a:rPr>
-              <a:t>)</a:t>
-            </a:r>
-          </a:p>
-          <a:p>
-            <a:pPr algn="l">
-              <a:spcAft>
-                <a:spcPts val="200"/>
-              </a:spcAft>
-            </a:pPr>
-            <a:r>
-              <a:rPr sz="1300" b="0">
-                <a:solidFill>
-                  <a:srgbClr val="1A1A1A"/>
-                </a:solidFill>
-                <a:latin typeface="Arial"/>
-              </a:rPr>
-              <a:t>ENA or PRBS/NRZ</a:t>
-            </a:r>
-          </a:p>
-        </p:txBody>
-      </p:sp>
-      <p:sp>
-        <p:nvSpPr>
-          <p:cNvPr id="6" name="Rounded Rectangle 5"/>
+              <a:t>Tables coupled_even.txt / coupled_odd.txt</a:t>
+            </a:r>
+          </a:p>
+          <a:p>
+            <a:pPr algn="l">
+              <a:spcAft>
+                <a:spcPts val="300"/>
+              </a:spcAft>
+            </a:pPr>
+            <a:r>
+              <a:rPr sz="1350" b="0">
+                <a:solidFill>
+                  <a:srgbClr val="1A1A1A"/>
+                </a:solidFill>
+                <a:latin typeface="Arial"/>
+              </a:rPr>
+              <a:t>Columns: frequency (Hz), loss (dB/m), microwave index, Re Z</a:t>
+            </a:r>
+            <a:r>
+              <a:rPr sz="1350" b="0" baseline="-25000">
+                <a:solidFill>
+                  <a:srgbClr val="1A1A1A"/>
+                </a:solidFill>
+                <a:latin typeface="Arial"/>
+              </a:rPr>
+              <a:t>0</a:t>
+            </a:r>
+            <a:r>
+              <a:rPr sz="1350" b="0">
+                <a:solidFill>
+                  <a:srgbClr val="1A1A1A"/>
+                </a:solidFill>
+                <a:latin typeface="Arial"/>
+              </a:rPr>
+              <a:t>, Im Z</a:t>
+            </a:r>
+            <a:r>
+              <a:rPr sz="1350" b="0" baseline="-25000">
+                <a:solidFill>
+                  <a:srgbClr val="1A1A1A"/>
+                </a:solidFill>
+                <a:latin typeface="Arial"/>
+              </a:rPr>
+              <a:t>0</a:t>
+            </a:r>
+            <a:r>
+              <a:rPr sz="1350" b="0">
+                <a:solidFill>
+                  <a:srgbClr val="1A1A1A"/>
+                </a:solidFill>
+                <a:latin typeface="Arial"/>
+              </a:rPr>
+              <a:t> (Ω).</a:t>
+            </a:r>
+          </a:p>
+          <a:p>
+            <a:pPr algn="l">
+              <a:spcAft>
+                <a:spcPts val="300"/>
+              </a:spcAft>
+            </a:pPr>
+            <a:r>
+              <a:rPr sz="1350" b="0">
+                <a:solidFill>
+                  <a:srgbClr val="1A1A1A"/>
+                </a:solidFill>
+                <a:latin typeface="Arial"/>
+              </a:rPr>
+              <a:t>Written by the GUI ("Export tables"): 3-D line fit ± the split (Δn × 1.146, δ = 0.61 %).</a:t>
+            </a:r>
+          </a:p>
+          <a:p>
+            <a:pPr algn="l">
+              <a:spcAft>
+                <a:spcPts val="300"/>
+              </a:spcAft>
+            </a:pPr>
+            <a:r>
+              <a:rPr sz="1350" b="0">
+                <a:solidFill>
+                  <a:srgbClr val="1A1A1A"/>
+                </a:solidFill>
+                <a:latin typeface="Arial"/>
+              </a:rPr>
+              <a:t>0.05 GHz to the Nyquist frequency; above 60 GHz, extrapolated with the single-line fit forms.</a:t>
+            </a:r>
+          </a:p>
+        </p:txBody>
+      </p:sp>
+      <p:sp>
+        <p:nvSpPr>
+          <p:cNvPr id="13" name="Rounded Rectangle 12"/>
           <p:cNvSpPr/>
           <p:nvPr/>
         </p:nvSpPr>
         <p:spPr>
           <a:xfrm>
-            <a:off x="457200" y="2743200"/>
-            <a:ext cx="2194560" cy="1005840"/>
+            <a:off x="6199632" y="3520440"/>
+            <a:ext cx="5550408" cy="2788920"/>
+          </a:xfrm>
+          <a:prstGeom prst="roundRect">
+            <a:avLst>
+              <a:gd name="adj" fmla="val 6000"/>
+            </a:avLst>
+          </a:prstGeom>
+          <a:solidFill>
+            <a:srgbClr val="F1F3F8"/>
+          </a:solidFill>
+          <a:ln>
+            <a:noFill/>
+          </a:ln>
+          <a:effectLst/>
+        </p:spPr>
+        <p:style>
+          <a:lnRef idx="1">
+            <a:schemeClr val="accent1"/>
+          </a:lnRef>
+          <a:fillRef idx="3">
+            <a:schemeClr val="accent1"/>
+          </a:fillRef>
+          <a:effectRef idx="2">
+            <a:schemeClr val="accent1"/>
+          </a:effectRef>
+          <a:fontRef idx="minor">
+            <a:schemeClr val="lt1"/>
+          </a:fontRef>
+        </p:style>
+        <p:txBody>
+          <a:bodyPr rtlCol="0" anchor="ctr"/>
+          <a:lstStyle/>
+          <a:p>
+            <a:pPr algn="ctr"/>
+          </a:p>
+        </p:txBody>
+      </p:sp>
+      <p:sp>
+        <p:nvSpPr>
+          <p:cNvPr id="14" name="TextBox 13"/>
+          <p:cNvSpPr txBox="1"/>
+          <p:nvPr/>
+        </p:nvSpPr>
+        <p:spPr>
+          <a:xfrm>
+            <a:off x="6336792" y="3593592"/>
+            <a:ext cx="5276088" cy="2679191"/>
+          </a:xfrm>
+          <a:prstGeom prst="rect">
+            <a:avLst/>
+          </a:prstGeom>
+          <a:noFill/>
+        </p:spPr>
+        <p:txBody>
+          <a:bodyPr wrap="square" lIns="36576" rIns="36576" tIns="18288" bIns="18288" anchor="t">
+            <a:spAutoFit/>
+          </a:bodyPr>
+          <a:lstStyle/>
+          <a:p>
+            <a:pPr algn="l">
+              <a:spcAft>
+                <a:spcPts val="300"/>
+              </a:spcAft>
+            </a:pPr>
+            <a:r>
+              <a:rPr sz="1500" b="1">
+                <a:solidFill>
+                  <a:srgbClr val="0E2268"/>
+                </a:solidFill>
+                <a:latin typeface="Arial"/>
+              </a:rPr>
+              <a:t>Code check</a:t>
+            </a:r>
+          </a:p>
+          <a:p>
+            <a:pPr algn="l">
+              <a:spcAft>
+                <a:spcPts val="300"/>
+              </a:spcAft>
+            </a:pPr>
+            <a:r>
+              <a:rPr sz="1350" b="0">
+                <a:solidFill>
+                  <a:srgbClr val="1A1A1A"/>
+                </a:solidFill>
+                <a:latin typeface="Arial"/>
+              </a:rPr>
+              <a:t>LSF code executed line by line vs Python twin: ≤ 4.5·10</a:t>
+            </a:r>
+            <a:r>
+              <a:rPr sz="1350" b="0" baseline="30000">
+                <a:solidFill>
+                  <a:srgbClr val="1A1A1A"/>
+                </a:solidFill>
+                <a:latin typeface="Arial"/>
+              </a:rPr>
+              <a:t>−14</a:t>
+            </a:r>
+            <a:r>
+              <a:rPr sz="1350" b="0">
+                <a:solidFill>
+                  <a:srgbClr val="1A1A1A"/>
+                </a:solidFill>
+                <a:latin typeface="Arial"/>
+              </a:rPr>
+              <a:t>.</a:t>
+            </a:r>
+          </a:p>
+          <a:p>
+            <a:pPr algn="l">
+              <a:spcAft>
+                <a:spcPts val="300"/>
+              </a:spcAft>
+            </a:pPr>
+            <a:r>
+              <a:rPr sz="1350" b="0">
+                <a:solidFill>
+                  <a:srgbClr val="1A1A1A"/>
+                </a:solidFill>
+                <a:latin typeface="Arial"/>
+              </a:rPr>
+              <a:t>INTERCONNECT run (14 mm): aggressor within 0.09 dB / 0.44°; crosstalk error 72–84 dB below the aggressor.</a:t>
+            </a:r>
+          </a:p>
+        </p:txBody>
+      </p:sp>
+    </p:spTree>
+  </p:cSld>
+  <p:clrMapOvr>
+    <a:masterClrMapping/>
+  </p:clrMapOvr>
+</p:sld>
+</file>
+
+<file path=ppt/slides/slide14.xml><?xml version="1.0" encoding="utf-8"?>
+<p:sld xmlns:a="http://schemas.openxmlformats.org/drawingml/2006/main" xmlns:p="http://schemas.openxmlformats.org/presentationml/2006/main" xmlns:r="http://schemas.openxmlformats.org/officeDocument/2006/relationships">
+  <p:cSld>
+    <p:spTree>
+      <p:nvGrpSpPr>
+        <p:cNvPr id="1" name=""/>
+        <p:cNvGrpSpPr/>
+        <p:nvPr/>
+      </p:nvGrpSpPr>
+      <p:grpSpPr/>
+      <p:sp>
+        <p:nvSpPr>
+          <p:cNvPr id="2" name="TextBox 1"/>
+          <p:cNvSpPr txBox="1"/>
+          <p:nvPr/>
+        </p:nvSpPr>
+        <p:spPr>
+          <a:xfrm>
+            <a:off x="502920" y="384048"/>
+            <a:ext cx="9692640" cy="640080"/>
+          </a:xfrm>
+          <a:prstGeom prst="rect">
+            <a:avLst/>
+          </a:prstGeom>
+          <a:noFill/>
+        </p:spPr>
+        <p:txBody>
+          <a:bodyPr wrap="square" lIns="36576" rIns="36576" tIns="18288" bIns="18288" anchor="t">
+            <a:spAutoFit/>
+          </a:bodyPr>
+          <a:lstStyle/>
+          <a:p>
+            <a:pPr algn="l">
+              <a:spcAft>
+                <a:spcPts val="400"/>
+              </a:spcAft>
+            </a:pPr>
+            <a:r>
+              <a:rPr sz="2800" b="0">
+                <a:solidFill>
+                  <a:srgbClr val="1A1A1A"/>
+                </a:solidFill>
+                <a:latin typeface="Arial"/>
+              </a:rPr>
+              <a:t>INTERCONNECT test bench (PAIR_MOD / FE / NE)</a:t>
+            </a:r>
+          </a:p>
+        </p:txBody>
+      </p:sp>
+      <p:sp>
+        <p:nvSpPr>
+          <p:cNvPr id="3" name="TextBox 2"/>
+          <p:cNvSpPr txBox="1"/>
+          <p:nvPr/>
+        </p:nvSpPr>
+        <p:spPr>
+          <a:xfrm>
+            <a:off x="548640" y="932688"/>
+            <a:ext cx="10789920" cy="365760"/>
+          </a:xfrm>
+          <a:prstGeom prst="rect">
+            <a:avLst/>
+          </a:prstGeom>
+          <a:noFill/>
+        </p:spPr>
+        <p:txBody>
+          <a:bodyPr wrap="square" lIns="36576" rIns="36576" tIns="18288" bIns="18288" anchor="t">
+            <a:spAutoFit/>
+          </a:bodyPr>
+          <a:lstStyle/>
+          <a:p>
+            <a:pPr algn="l">
+              <a:spcAft>
+                <a:spcPts val="400"/>
+              </a:spcAft>
+            </a:pPr>
+            <a:r>
+              <a:rPr sz="1500" b="1">
+                <a:solidFill>
+                  <a:srgbClr val="0E2268"/>
+                </a:solidFill>
+                <a:latin typeface="Arial"/>
+              </a:rPr>
+              <a:t>Isolates the element: driver, idle victim driver, two terminations, analyser</a:t>
+            </a:r>
+          </a:p>
+        </p:txBody>
+      </p:sp>
+      <p:sp>
+        <p:nvSpPr>
+          <p:cNvPr id="4" name="Rounded Rectangle 3"/>
+          <p:cNvSpPr/>
+          <p:nvPr/>
+        </p:nvSpPr>
+        <p:spPr>
+          <a:xfrm>
+            <a:off x="457200" y="1508760"/>
+            <a:ext cx="2606040" cy="1234440"/>
           </a:xfrm>
           <a:prstGeom prst="roundRect">
             <a:avLst>
@@ -6957,6 +7556,1121 @@
       </p:sp>
       <p:sp>
         <p:nvSpPr>
+          <p:cNvPr id="5" name="TextBox 4"/>
+          <p:cNvSpPr txBox="1"/>
+          <p:nvPr/>
+        </p:nvSpPr>
+        <p:spPr>
+          <a:xfrm>
+            <a:off x="548640" y="1581912"/>
+            <a:ext cx="2423160" cy="1143000"/>
+          </a:xfrm>
+          <a:prstGeom prst="rect">
+            <a:avLst/>
+          </a:prstGeom>
+          <a:noFill/>
+        </p:spPr>
+        <p:txBody>
+          <a:bodyPr wrap="square" lIns="36576" rIns="36576" tIns="18288" bIns="18288" anchor="t">
+            <a:spAutoFit/>
+          </a:bodyPr>
+          <a:lstStyle/>
+          <a:p>
+            <a:pPr algn="l">
+              <a:spcAft>
+                <a:spcPts val="200"/>
+              </a:spcAft>
+            </a:pPr>
+            <a:r>
+              <a:rPr sz="1400" b="1">
+                <a:solidFill>
+                  <a:srgbClr val="0E2268"/>
+                </a:solidFill>
+                <a:latin typeface="Arial"/>
+              </a:rPr>
+              <a:t>ENA</a:t>
+            </a:r>
+          </a:p>
+          <a:p>
+            <a:pPr algn="l">
+              <a:spcAft>
+                <a:spcPts val="200"/>
+              </a:spcAft>
+            </a:pPr>
+            <a:r>
+              <a:rPr sz="1300" b="0">
+                <a:solidFill>
+                  <a:srgbClr val="1A1A1A"/>
+                </a:solidFill>
+                <a:latin typeface="Arial"/>
+              </a:rPr>
+              <a:t>output → driver</a:t>
+            </a:r>
+          </a:p>
+          <a:p>
+            <a:pPr algn="l">
+              <a:spcAft>
+                <a:spcPts val="200"/>
+              </a:spcAft>
+            </a:pPr>
+            <a:r>
+              <a:rPr sz="1300" b="0">
+                <a:solidFill>
+                  <a:srgbClr val="1A1A1A"/>
+                </a:solidFill>
+                <a:latin typeface="Arial"/>
+              </a:rPr>
+              <a:t>inputs 1, 2 ← two outputs</a:t>
+            </a:r>
+          </a:p>
+        </p:txBody>
+      </p:sp>
+      <p:sp>
+        <p:nvSpPr>
+          <p:cNvPr id="6" name="Right Arrow 5"/>
+          <p:cNvSpPr/>
+          <p:nvPr/>
+        </p:nvSpPr>
+        <p:spPr>
+          <a:xfrm>
+            <a:off x="3090672" y="1965960"/>
+            <a:ext cx="228600" cy="365760"/>
+          </a:xfrm>
+          <a:prstGeom prst="rightArrow">
+            <a:avLst/>
+          </a:prstGeom>
+          <a:solidFill>
+            <a:srgbClr val="5A606E"/>
+          </a:solidFill>
+          <a:ln>
+            <a:noFill/>
+          </a:ln>
+          <a:effectLst/>
+        </p:spPr>
+        <p:style>
+          <a:lnRef idx="1">
+            <a:schemeClr val="accent1"/>
+          </a:lnRef>
+          <a:fillRef idx="3">
+            <a:schemeClr val="accent1"/>
+          </a:fillRef>
+          <a:effectRef idx="2">
+            <a:schemeClr val="accent1"/>
+          </a:effectRef>
+          <a:fontRef idx="minor">
+            <a:schemeClr val="lt1"/>
+          </a:fontRef>
+        </p:style>
+        <p:txBody>
+          <a:bodyPr rtlCol="0" anchor="ctr"/>
+          <a:lstStyle/>
+          <a:p>
+            <a:pPr algn="ctr"/>
+          </a:p>
+        </p:txBody>
+      </p:sp>
+      <p:sp>
+        <p:nvSpPr>
+          <p:cNvPr id="7" name="Rounded Rectangle 6"/>
+          <p:cNvSpPr/>
+          <p:nvPr/>
+        </p:nvSpPr>
+        <p:spPr>
+          <a:xfrm>
+            <a:off x="3337560" y="1508760"/>
+            <a:ext cx="2606040" cy="1234440"/>
+          </a:xfrm>
+          <a:prstGeom prst="roundRect">
+            <a:avLst>
+              <a:gd name="adj" fmla="val 6000"/>
+            </a:avLst>
+          </a:prstGeom>
+          <a:solidFill>
+            <a:srgbClr val="F1F3F8"/>
+          </a:solidFill>
+          <a:ln w="15875">
+            <a:solidFill>
+              <a:srgbClr val="D9DCE3"/>
+            </a:solidFill>
+          </a:ln>
+          <a:effectLst/>
+        </p:spPr>
+        <p:style>
+          <a:lnRef idx="1">
+            <a:schemeClr val="accent1"/>
+          </a:lnRef>
+          <a:fillRef idx="3">
+            <a:schemeClr val="accent1"/>
+          </a:fillRef>
+          <a:effectRef idx="2">
+            <a:schemeClr val="accent1"/>
+          </a:effectRef>
+          <a:fontRef idx="minor">
+            <a:schemeClr val="lt1"/>
+          </a:fontRef>
+        </p:style>
+        <p:txBody>
+          <a:bodyPr rtlCol="0" anchor="ctr"/>
+          <a:lstStyle/>
+          <a:p>
+            <a:pPr algn="ctr"/>
+          </a:p>
+        </p:txBody>
+      </p:sp>
+      <p:sp>
+        <p:nvSpPr>
+          <p:cNvPr id="8" name="TextBox 7"/>
+          <p:cNvSpPr txBox="1"/>
+          <p:nvPr/>
+        </p:nvSpPr>
+        <p:spPr>
+          <a:xfrm>
+            <a:off x="3429000" y="1581912"/>
+            <a:ext cx="2423160" cy="1143000"/>
+          </a:xfrm>
+          <a:prstGeom prst="rect">
+            <a:avLst/>
+          </a:prstGeom>
+          <a:noFill/>
+        </p:spPr>
+        <p:txBody>
+          <a:bodyPr wrap="square" lIns="36576" rIns="36576" tIns="18288" bIns="18288" anchor="t">
+            <a:spAutoFit/>
+          </a:bodyPr>
+          <a:lstStyle/>
+          <a:p>
+            <a:pPr algn="l">
+              <a:spcAft>
+                <a:spcPts val="200"/>
+              </a:spcAft>
+            </a:pPr>
+            <a:r>
+              <a:rPr sz="1400" b="1">
+                <a:solidFill>
+                  <a:srgbClr val="0E2268"/>
+                </a:solidFill>
+                <a:latin typeface="Arial"/>
+              </a:rPr>
+              <a:t>SRC</a:t>
+            </a:r>
+          </a:p>
+          <a:p>
+            <a:pPr algn="l">
+              <a:spcAft>
+                <a:spcPts val="200"/>
+              </a:spcAft>
+            </a:pPr>
+            <a:r>
+              <a:rPr sz="1300" b="0">
+                <a:solidFill>
+                  <a:srgbClr val="1A1A1A"/>
+                </a:solidFill>
+                <a:latin typeface="Arial"/>
+              </a:rPr>
+              <a:t>driver, Z</a:t>
+            </a:r>
+            <a:r>
+              <a:rPr sz="1300" b="0" baseline="-25000">
+                <a:solidFill>
+                  <a:srgbClr val="1A1A1A"/>
+                </a:solidFill>
+                <a:latin typeface="Arial"/>
+              </a:rPr>
+              <a:t>s</a:t>
+            </a:r>
+          </a:p>
+        </p:txBody>
+      </p:sp>
+      <p:sp>
+        <p:nvSpPr>
+          <p:cNvPr id="9" name="Right Arrow 8"/>
+          <p:cNvSpPr/>
+          <p:nvPr/>
+        </p:nvSpPr>
+        <p:spPr>
+          <a:xfrm>
+            <a:off x="5971031" y="1965960"/>
+            <a:ext cx="228600" cy="365760"/>
+          </a:xfrm>
+          <a:prstGeom prst="rightArrow">
+            <a:avLst/>
+          </a:prstGeom>
+          <a:solidFill>
+            <a:srgbClr val="5A606E"/>
+          </a:solidFill>
+          <a:ln>
+            <a:noFill/>
+          </a:ln>
+          <a:effectLst/>
+        </p:spPr>
+        <p:style>
+          <a:lnRef idx="1">
+            <a:schemeClr val="accent1"/>
+          </a:lnRef>
+          <a:fillRef idx="3">
+            <a:schemeClr val="accent1"/>
+          </a:fillRef>
+          <a:effectRef idx="2">
+            <a:schemeClr val="accent1"/>
+          </a:effectRef>
+          <a:fontRef idx="minor">
+            <a:schemeClr val="lt1"/>
+          </a:fontRef>
+        </p:style>
+        <p:txBody>
+          <a:bodyPr rtlCol="0" anchor="ctr"/>
+          <a:lstStyle/>
+          <a:p>
+            <a:pPr algn="ctr"/>
+          </a:p>
+        </p:txBody>
+      </p:sp>
+      <p:sp>
+        <p:nvSpPr>
+          <p:cNvPr id="10" name="Rounded Rectangle 9"/>
+          <p:cNvSpPr/>
+          <p:nvPr/>
+        </p:nvSpPr>
+        <p:spPr>
+          <a:xfrm>
+            <a:off x="6217920" y="1508760"/>
+            <a:ext cx="2606040" cy="1234440"/>
+          </a:xfrm>
+          <a:prstGeom prst="roundRect">
+            <a:avLst>
+              <a:gd name="adj" fmla="val 6000"/>
+            </a:avLst>
+          </a:prstGeom>
+          <a:solidFill>
+            <a:srgbClr val="F1F3F8"/>
+          </a:solidFill>
+          <a:ln w="15875">
+            <a:solidFill>
+              <a:srgbClr val="D9DCE3"/>
+            </a:solidFill>
+          </a:ln>
+          <a:effectLst/>
+        </p:spPr>
+        <p:style>
+          <a:lnRef idx="1">
+            <a:schemeClr val="accent1"/>
+          </a:lnRef>
+          <a:fillRef idx="3">
+            <a:schemeClr val="accent1"/>
+          </a:fillRef>
+          <a:effectRef idx="2">
+            <a:schemeClr val="accent1"/>
+          </a:effectRef>
+          <a:fontRef idx="minor">
+            <a:schemeClr val="lt1"/>
+          </a:fontRef>
+        </p:style>
+        <p:txBody>
+          <a:bodyPr rtlCol="0" anchor="ctr"/>
+          <a:lstStyle/>
+          <a:p>
+            <a:pPr algn="ctr"/>
+          </a:p>
+        </p:txBody>
+      </p:sp>
+      <p:sp>
+        <p:nvSpPr>
+          <p:cNvPr id="11" name="TextBox 10"/>
+          <p:cNvSpPr txBox="1"/>
+          <p:nvPr/>
+        </p:nvSpPr>
+        <p:spPr>
+          <a:xfrm>
+            <a:off x="6309359" y="1581912"/>
+            <a:ext cx="2423160" cy="1143000"/>
+          </a:xfrm>
+          <a:prstGeom prst="rect">
+            <a:avLst/>
+          </a:prstGeom>
+          <a:noFill/>
+        </p:spPr>
+        <p:txBody>
+          <a:bodyPr wrap="square" lIns="36576" rIns="36576" tIns="18288" bIns="18288" anchor="t">
+            <a:spAutoFit/>
+          </a:bodyPr>
+          <a:lstStyle/>
+          <a:p>
+            <a:pPr algn="l">
+              <a:spcAft>
+                <a:spcPts val="200"/>
+              </a:spcAft>
+            </a:pPr>
+            <a:r>
+              <a:rPr sz="1400" b="1">
+                <a:solidFill>
+                  <a:srgbClr val="0E2268"/>
+                </a:solidFill>
+                <a:latin typeface="Arial"/>
+              </a:rPr>
+              <a:t>CTL</a:t>
+            </a:r>
+          </a:p>
+          <a:p>
+            <a:pPr algn="l">
+              <a:spcAft>
+                <a:spcPts val="200"/>
+              </a:spcAft>
+            </a:pPr>
+            <a:r>
+              <a:rPr sz="1300" b="0">
+                <a:solidFill>
+                  <a:srgbClr val="1A1A1A"/>
+                </a:solidFill>
+                <a:latin typeface="Arial"/>
+              </a:rPr>
+              <a:t>Coupled TL element</a:t>
+            </a:r>
+          </a:p>
+        </p:txBody>
+      </p:sp>
+      <p:sp>
+        <p:nvSpPr>
+          <p:cNvPr id="12" name="Right Arrow 11"/>
+          <p:cNvSpPr/>
+          <p:nvPr/>
+        </p:nvSpPr>
+        <p:spPr>
+          <a:xfrm>
+            <a:off x="8851392" y="1965960"/>
+            <a:ext cx="228600" cy="365760"/>
+          </a:xfrm>
+          <a:prstGeom prst="rightArrow">
+            <a:avLst/>
+          </a:prstGeom>
+          <a:solidFill>
+            <a:srgbClr val="5A606E"/>
+          </a:solidFill>
+          <a:ln>
+            <a:noFill/>
+          </a:ln>
+          <a:effectLst/>
+        </p:spPr>
+        <p:style>
+          <a:lnRef idx="1">
+            <a:schemeClr val="accent1"/>
+          </a:lnRef>
+          <a:fillRef idx="3">
+            <a:schemeClr val="accent1"/>
+          </a:fillRef>
+          <a:effectRef idx="2">
+            <a:schemeClr val="accent1"/>
+          </a:effectRef>
+          <a:fontRef idx="minor">
+            <a:schemeClr val="lt1"/>
+          </a:fontRef>
+        </p:style>
+        <p:txBody>
+          <a:bodyPr rtlCol="0" anchor="ctr"/>
+          <a:lstStyle/>
+          <a:p>
+            <a:pPr algn="ctr"/>
+          </a:p>
+        </p:txBody>
+      </p:sp>
+      <p:sp>
+        <p:nvSpPr>
+          <p:cNvPr id="13" name="Rounded Rectangle 12"/>
+          <p:cNvSpPr/>
+          <p:nvPr/>
+        </p:nvSpPr>
+        <p:spPr>
+          <a:xfrm>
+            <a:off x="9098280" y="1508760"/>
+            <a:ext cx="2606040" cy="1234440"/>
+          </a:xfrm>
+          <a:prstGeom prst="roundRect">
+            <a:avLst>
+              <a:gd name="adj" fmla="val 6000"/>
+            </a:avLst>
+          </a:prstGeom>
+          <a:solidFill>
+            <a:srgbClr val="F1F3F8"/>
+          </a:solidFill>
+          <a:ln w="15875">
+            <a:solidFill>
+              <a:srgbClr val="D9DCE3"/>
+            </a:solidFill>
+          </a:ln>
+          <a:effectLst/>
+        </p:spPr>
+        <p:style>
+          <a:lnRef idx="1">
+            <a:schemeClr val="accent1"/>
+          </a:lnRef>
+          <a:fillRef idx="3">
+            <a:schemeClr val="accent1"/>
+          </a:fillRef>
+          <a:effectRef idx="2">
+            <a:schemeClr val="accent1"/>
+          </a:effectRef>
+          <a:fontRef idx="minor">
+            <a:schemeClr val="lt1"/>
+          </a:fontRef>
+        </p:style>
+        <p:txBody>
+          <a:bodyPr rtlCol="0" anchor="ctr"/>
+          <a:lstStyle/>
+          <a:p>
+            <a:pPr algn="ctr"/>
+          </a:p>
+        </p:txBody>
+      </p:sp>
+      <p:sp>
+        <p:nvSpPr>
+          <p:cNvPr id="14" name="TextBox 13"/>
+          <p:cNvSpPr txBox="1"/>
+          <p:nvPr/>
+        </p:nvSpPr>
+        <p:spPr>
+          <a:xfrm>
+            <a:off x="9189719" y="1581912"/>
+            <a:ext cx="2423160" cy="1143000"/>
+          </a:xfrm>
+          <a:prstGeom prst="rect">
+            <a:avLst/>
+          </a:prstGeom>
+          <a:noFill/>
+        </p:spPr>
+        <p:txBody>
+          <a:bodyPr wrap="square" lIns="36576" rIns="36576" tIns="18288" bIns="18288" anchor="t">
+            <a:spAutoFit/>
+          </a:bodyPr>
+          <a:lstStyle/>
+          <a:p>
+            <a:pPr algn="l">
+              <a:spcAft>
+                <a:spcPts val="200"/>
+              </a:spcAft>
+            </a:pPr>
+            <a:r>
+              <a:rPr sz="1400" b="1">
+                <a:solidFill>
+                  <a:srgbClr val="0E2268"/>
+                </a:solidFill>
+                <a:latin typeface="Arial"/>
+              </a:rPr>
+              <a:t>LOAD_A2 / B2</a:t>
+            </a:r>
+          </a:p>
+          <a:p>
+            <a:pPr algn="l">
+              <a:spcAft>
+                <a:spcPts val="200"/>
+              </a:spcAft>
+            </a:pPr>
+            <a:r>
+              <a:rPr sz="1300" b="0">
+                <a:solidFill>
+                  <a:srgbClr val="1A1A1A"/>
+                </a:solidFill>
+                <a:latin typeface="Arial"/>
+              </a:rPr>
+              <a:t>terminations R</a:t>
+            </a:r>
+            <a:r>
+              <a:rPr sz="1300" b="0" baseline="-25000">
+                <a:solidFill>
+                  <a:srgbClr val="1A1A1A"/>
+                </a:solidFill>
+                <a:latin typeface="Arial"/>
+              </a:rPr>
+              <a:t>t</a:t>
+            </a:r>
+          </a:p>
+        </p:txBody>
+      </p:sp>
+      <p:sp>
+        <p:nvSpPr>
+          <p:cNvPr id="15" name="Rounded Rectangle 14"/>
+          <p:cNvSpPr/>
+          <p:nvPr/>
+        </p:nvSpPr>
+        <p:spPr>
+          <a:xfrm>
+            <a:off x="457200" y="2971800"/>
+            <a:ext cx="5532120" cy="3337560"/>
+          </a:xfrm>
+          <a:prstGeom prst="roundRect">
+            <a:avLst>
+              <a:gd name="adj" fmla="val 6000"/>
+            </a:avLst>
+          </a:prstGeom>
+          <a:solidFill>
+            <a:srgbClr val="F1F3F8"/>
+          </a:solidFill>
+          <a:ln>
+            <a:noFill/>
+          </a:ln>
+          <a:effectLst/>
+        </p:spPr>
+        <p:style>
+          <a:lnRef idx="1">
+            <a:schemeClr val="accent1"/>
+          </a:lnRef>
+          <a:fillRef idx="3">
+            <a:schemeClr val="accent1"/>
+          </a:fillRef>
+          <a:effectRef idx="2">
+            <a:schemeClr val="accent1"/>
+          </a:effectRef>
+          <a:fontRef idx="minor">
+            <a:schemeClr val="lt1"/>
+          </a:fontRef>
+        </p:style>
+        <p:txBody>
+          <a:bodyPr rtlCol="0" anchor="ctr"/>
+          <a:lstStyle/>
+          <a:p>
+            <a:pPr algn="ctr"/>
+          </a:p>
+        </p:txBody>
+      </p:sp>
+      <p:sp>
+        <p:nvSpPr>
+          <p:cNvPr id="16" name="TextBox 15"/>
+          <p:cNvSpPr txBox="1"/>
+          <p:nvPr/>
+        </p:nvSpPr>
+        <p:spPr>
+          <a:xfrm>
+            <a:off x="594360" y="3044952"/>
+            <a:ext cx="5257800" cy="3227832"/>
+          </a:xfrm>
+          <a:prstGeom prst="rect">
+            <a:avLst/>
+          </a:prstGeom>
+          <a:noFill/>
+        </p:spPr>
+        <p:txBody>
+          <a:bodyPr wrap="square" lIns="36576" rIns="36576" tIns="18288" bIns="18288" anchor="t">
+            <a:spAutoFit/>
+          </a:bodyPr>
+          <a:lstStyle/>
+          <a:p>
+            <a:pPr algn="l">
+              <a:spcAft>
+                <a:spcPts val="300"/>
+              </a:spcAft>
+            </a:pPr>
+            <a:r>
+              <a:rPr sz="1500" b="1">
+                <a:solidFill>
+                  <a:srgbClr val="0E2268"/>
+                </a:solidFill>
+                <a:latin typeface="Arial"/>
+              </a:rPr>
+              <a:t>Why this form</a:t>
+            </a:r>
+          </a:p>
+          <a:p>
+            <a:pPr algn="l">
+              <a:spcAft>
+                <a:spcPts val="300"/>
+              </a:spcAft>
+            </a:pPr>
+            <a:r>
+              <a:rPr sz="1350" b="0">
+                <a:solidFill>
+                  <a:srgbClr val="1A1A1A"/>
+                </a:solidFill>
+                <a:latin typeface="Arial"/>
+              </a:rPr>
+              <a:t>LOAD_B1 = Z</a:t>
+            </a:r>
+            <a:r>
+              <a:rPr sz="1350" b="0" baseline="-25000">
+                <a:solidFill>
+                  <a:srgbClr val="1A1A1A"/>
+                </a:solidFill>
+                <a:latin typeface="Arial"/>
+              </a:rPr>
+              <a:t>s</a:t>
+            </a:r>
+            <a:r>
+              <a:rPr sz="1350" b="0">
+                <a:solidFill>
+                  <a:srgbClr val="1A1A1A"/>
+                </a:solidFill>
+                <a:latin typeface="Arial"/>
+              </a:rPr>
+              <a:t>: victim's input on its own idle driver.</a:t>
+            </a:r>
+          </a:p>
+          <a:p>
+            <a:pPr algn="l">
+              <a:spcAft>
+                <a:spcPts val="300"/>
+              </a:spcAft>
+            </a:pPr>
+            <a:r>
+              <a:rPr sz="1350" b="0">
+                <a:solidFill>
+                  <a:srgbClr val="1A1A1A"/>
+                </a:solidFill>
+                <a:latin typeface="Arial"/>
+              </a:rPr>
+              <a:t>Compound with scattering-data analysis on: only there are reflections exact (Step 0 result).</a:t>
+            </a:r>
+          </a:p>
+          <a:p>
+            <a:pPr algn="l">
+              <a:spcAft>
+                <a:spcPts val="300"/>
+              </a:spcAft>
+            </a:pPr>
+            <a:r>
+              <a:rPr sz="1350" b="0">
+                <a:solidFill>
+                  <a:srgbClr val="1A1A1A"/>
+                </a:solidFill>
+                <a:latin typeface="Arial"/>
+              </a:rPr>
+              <a:t>Three rows: an analyser reads two outputs; MOD = modulation A/B, FE = far end, NE = near end.</a:t>
+            </a:r>
+          </a:p>
+        </p:txBody>
+      </p:sp>
+      <p:sp>
+        <p:nvSpPr>
+          <p:cNvPr id="17" name="Rounded Rectangle 16"/>
+          <p:cNvSpPr/>
+          <p:nvPr/>
+        </p:nvSpPr>
+        <p:spPr>
+          <a:xfrm>
+            <a:off x="6199632" y="2971800"/>
+            <a:ext cx="5550408" cy="3337560"/>
+          </a:xfrm>
+          <a:prstGeom prst="roundRect">
+            <a:avLst>
+              <a:gd name="adj" fmla="val 6000"/>
+            </a:avLst>
+          </a:prstGeom>
+          <a:solidFill>
+            <a:srgbClr val="F1F3F8"/>
+          </a:solidFill>
+          <a:ln>
+            <a:noFill/>
+          </a:ln>
+          <a:effectLst/>
+        </p:spPr>
+        <p:style>
+          <a:lnRef idx="1">
+            <a:schemeClr val="accent1"/>
+          </a:lnRef>
+          <a:fillRef idx="3">
+            <a:schemeClr val="accent1"/>
+          </a:fillRef>
+          <a:effectRef idx="2">
+            <a:schemeClr val="accent1"/>
+          </a:effectRef>
+          <a:fontRef idx="minor">
+            <a:schemeClr val="lt1"/>
+          </a:fontRef>
+        </p:style>
+        <p:txBody>
+          <a:bodyPr rtlCol="0" anchor="ctr"/>
+          <a:lstStyle/>
+          <a:p>
+            <a:pPr algn="ctr"/>
+          </a:p>
+        </p:txBody>
+      </p:sp>
+      <p:sp>
+        <p:nvSpPr>
+          <p:cNvPr id="18" name="TextBox 17"/>
+          <p:cNvSpPr txBox="1"/>
+          <p:nvPr/>
+        </p:nvSpPr>
+        <p:spPr>
+          <a:xfrm>
+            <a:off x="6336792" y="3044952"/>
+            <a:ext cx="5276088" cy="3227832"/>
+          </a:xfrm>
+          <a:prstGeom prst="rect">
+            <a:avLst/>
+          </a:prstGeom>
+          <a:noFill/>
+        </p:spPr>
+        <p:txBody>
+          <a:bodyPr wrap="square" lIns="36576" rIns="36576" tIns="18288" bIns="18288" anchor="t">
+            <a:spAutoFit/>
+          </a:bodyPr>
+          <a:lstStyle/>
+          <a:p>
+            <a:pPr algn="l">
+              <a:spcAft>
+                <a:spcPts val="300"/>
+              </a:spcAft>
+            </a:pPr>
+            <a:r>
+              <a:rPr sz="1400" b="1">
+                <a:solidFill>
+                  <a:srgbClr val="0E2268"/>
+                </a:solidFill>
+                <a:latin typeface="Arial"/>
+              </a:rPr>
+              <a:t>What is compared</a:t>
+            </a:r>
+          </a:p>
+          <a:p>
+            <a:pPr algn="l">
+              <a:spcAft>
+                <a:spcPts val="300"/>
+              </a:spcAft>
+            </a:pPr>
+            <a:r>
+              <a:rPr sz="1250" b="0">
+                <a:solidFill>
+                  <a:srgbClr val="1A1A1A"/>
+                </a:solidFill>
+                <a:latin typeface="Arial"/>
+              </a:rPr>
+              <a:t>The element's outputs are electrical voltages: 'modulation A/B' = H</a:t>
+            </a:r>
+            <a:r>
+              <a:rPr sz="1250" b="0" baseline="-25000">
+                <a:solidFill>
+                  <a:srgbClr val="1A1A1A"/>
+                </a:solidFill>
+                <a:latin typeface="Arial"/>
+              </a:rPr>
+              <a:t>A</a:t>
+            </a:r>
+            <a:r>
+              <a:rPr sz="1250" b="0">
+                <a:solidFill>
+                  <a:srgbClr val="1A1A1A"/>
+                </a:solidFill>
+                <a:latin typeface="Arial"/>
+              </a:rPr>
+              <a:t>, H</a:t>
+            </a:r>
+            <a:r>
+              <a:rPr sz="1250" b="0" baseline="-25000">
+                <a:solidFill>
+                  <a:srgbClr val="1A1A1A"/>
+                </a:solidFill>
+                <a:latin typeface="Arial"/>
+              </a:rPr>
+              <a:t>B</a:t>
+            </a:r>
+            <a:r>
+              <a:rPr sz="1250" b="0">
+                <a:solidFill>
+                  <a:srgbClr val="1A1A1A"/>
+                </a:solidFill>
+                <a:latin typeface="Arial"/>
+              </a:rPr>
+              <a:t>, the voltages the light integrates (previous slides). The ENA reads them as complex transfer functions.</a:t>
+            </a:r>
+          </a:p>
+          <a:p>
+            <a:pPr algn="l">
+              <a:spcAft>
+                <a:spcPts val="300"/>
+              </a:spcAft>
+            </a:pPr>
+            <a:r>
+              <a:rPr sz="1250" b="0">
+                <a:solidFill>
+                  <a:srgbClr val="1A1A1A"/>
+                </a:solidFill>
+                <a:latin typeface="Arial"/>
+              </a:rPr>
+              <a:t>Scale (2.00: ENA source = half the EMF), FIR latency (341 ps) and phase convention are taken from A; the same corrections are applied to B.</a:t>
+            </a:r>
+          </a:p>
+          <a:p>
+            <a:pPr algn="l">
+              <a:spcAft>
+                <a:spcPts val="300"/>
+              </a:spcAft>
+            </a:pPr>
+            <a:r>
+              <a:rPr sz="1250" b="0">
+                <a:solidFill>
+                  <a:srgbClr val="1A1A1A"/>
+                </a:solidFill>
+                <a:latin typeface="Arial"/>
+              </a:rPr>
+              <a:t>Optical EO response (photodiode): checked for the single line (Step 1, 0.1 dB); for the pair it comes with the full cascade run.</a:t>
+            </a:r>
+          </a:p>
+        </p:txBody>
+      </p:sp>
+    </p:spTree>
+  </p:cSld>
+  <p:clrMapOvr>
+    <a:masterClrMapping/>
+  </p:clrMapOvr>
+</p:sld>
+</file>
+
+<file path=ppt/slides/slide15.xml><?xml version="1.0" encoding="utf-8"?>
+<p:sld xmlns:a="http://schemas.openxmlformats.org/drawingml/2006/main" xmlns:p="http://schemas.openxmlformats.org/presentationml/2006/main" xmlns:r="http://schemas.openxmlformats.org/officeDocument/2006/relationships">
+  <p:cSld>
+    <p:spTree>
+      <p:nvGrpSpPr>
+        <p:cNvPr id="1" name=""/>
+        <p:cNvGrpSpPr/>
+        <p:nvPr/>
+      </p:nvGrpSpPr>
+      <p:grpSpPr/>
+      <p:sp>
+        <p:nvSpPr>
+          <p:cNvPr id="2" name="TextBox 1"/>
+          <p:cNvSpPr txBox="1"/>
+          <p:nvPr/>
+        </p:nvSpPr>
+        <p:spPr>
+          <a:xfrm>
+            <a:off x="502920" y="384048"/>
+            <a:ext cx="9692640" cy="640080"/>
+          </a:xfrm>
+          <a:prstGeom prst="rect">
+            <a:avLst/>
+          </a:prstGeom>
+          <a:noFill/>
+        </p:spPr>
+        <p:txBody>
+          <a:bodyPr wrap="square" lIns="36576" rIns="36576" tIns="18288" bIns="18288" anchor="t">
+            <a:spAutoFit/>
+          </a:bodyPr>
+          <a:lstStyle/>
+          <a:p>
+            <a:pPr algn="l">
+              <a:spcAft>
+                <a:spcPts val="400"/>
+              </a:spcAft>
+            </a:pPr>
+            <a:r>
+              <a:rPr sz="2800" b="0">
+                <a:solidFill>
+                  <a:srgbClr val="1A1A1A"/>
+                </a:solidFill>
+                <a:latin typeface="Arial"/>
+              </a:rPr>
+              <a:t>Full MZM cascade in crosstalk mode</a:t>
+            </a:r>
+          </a:p>
+        </p:txBody>
+      </p:sp>
+      <p:sp>
+        <p:nvSpPr>
+          <p:cNvPr id="3" name="TextBox 2"/>
+          <p:cNvSpPr txBox="1"/>
+          <p:nvPr/>
+        </p:nvSpPr>
+        <p:spPr>
+          <a:xfrm>
+            <a:off x="548640" y="932688"/>
+            <a:ext cx="10789920" cy="365760"/>
+          </a:xfrm>
+          <a:prstGeom prst="rect">
+            <a:avLst/>
+          </a:prstGeom>
+          <a:noFill/>
+        </p:spPr>
+        <p:txBody>
+          <a:bodyPr wrap="square" lIns="36576" rIns="36576" tIns="18288" bIns="18288" anchor="t">
+            <a:spAutoFit/>
+          </a:bodyPr>
+          <a:lstStyle/>
+          <a:p>
+            <a:pPr algn="l">
+              <a:spcAft>
+                <a:spcPts val="400"/>
+              </a:spcAft>
+            </a:pPr>
+            <a:r>
+              <a:rPr sz="1500" b="1">
+                <a:solidFill>
+                  <a:srgbClr val="0E2268"/>
+                </a:solidFill>
+                <a:latin typeface="Arial"/>
+              </a:rPr>
+              <a:t>Two modulators on one coupled electrode; built and dry-run, first INTERCONNECT run pending</a:t>
+            </a:r>
+          </a:p>
+        </p:txBody>
+      </p:sp>
+      <p:sp>
+        <p:nvSpPr>
+          <p:cNvPr id="4" name="Rounded Rectangle 3"/>
+          <p:cNvSpPr/>
+          <p:nvPr/>
+        </p:nvSpPr>
+        <p:spPr>
+          <a:xfrm>
+            <a:off x="457200" y="1463040"/>
+            <a:ext cx="2194560" cy="1005840"/>
+          </a:xfrm>
+          <a:prstGeom prst="roundRect">
+            <a:avLst>
+              <a:gd name="adj" fmla="val 6000"/>
+            </a:avLst>
+          </a:prstGeom>
+          <a:solidFill>
+            <a:srgbClr val="F1F3F8"/>
+          </a:solidFill>
+          <a:ln w="15875">
+            <a:solidFill>
+              <a:srgbClr val="D9DCE3"/>
+            </a:solidFill>
+          </a:ln>
+          <a:effectLst/>
+        </p:spPr>
+        <p:style>
+          <a:lnRef idx="1">
+            <a:schemeClr val="accent1"/>
+          </a:lnRef>
+          <a:fillRef idx="3">
+            <a:schemeClr val="accent1"/>
+          </a:fillRef>
+          <a:effectRef idx="2">
+            <a:schemeClr val="accent1"/>
+          </a:effectRef>
+          <a:fontRef idx="minor">
+            <a:schemeClr val="lt1"/>
+          </a:fontRef>
+        </p:style>
+        <p:txBody>
+          <a:bodyPr rtlCol="0" anchor="ctr"/>
+          <a:lstStyle/>
+          <a:p>
+            <a:pPr algn="ctr"/>
+          </a:p>
+        </p:txBody>
+      </p:sp>
+      <p:sp>
+        <p:nvSpPr>
+          <p:cNvPr id="5" name="TextBox 4"/>
+          <p:cNvSpPr txBox="1"/>
+          <p:nvPr/>
+        </p:nvSpPr>
+        <p:spPr>
+          <a:xfrm>
+            <a:off x="548640" y="1536192"/>
+            <a:ext cx="2011679" cy="914400"/>
+          </a:xfrm>
+          <a:prstGeom prst="rect">
+            <a:avLst/>
+          </a:prstGeom>
+          <a:noFill/>
+        </p:spPr>
+        <p:txBody>
+          <a:bodyPr wrap="square" lIns="36576" rIns="36576" tIns="18288" bIns="18288" anchor="t">
+            <a:spAutoFit/>
+          </a:bodyPr>
+          <a:lstStyle/>
+          <a:p>
+            <a:pPr algn="l">
+              <a:spcAft>
+                <a:spcPts val="200"/>
+              </a:spcAft>
+            </a:pPr>
+            <a:r>
+              <a:rPr sz="1400" b="1">
+                <a:solidFill>
+                  <a:srgbClr val="0E2268"/>
+                </a:solidFill>
+                <a:latin typeface="Arial"/>
+              </a:rPr>
+              <a:t>Driver A (Z</a:t>
+            </a:r>
+            <a:r>
+              <a:rPr sz="1400" b="1" baseline="-25000">
+                <a:solidFill>
+                  <a:srgbClr val="0E2268"/>
+                </a:solidFill>
+                <a:latin typeface="Arial"/>
+              </a:rPr>
+              <a:t>s</a:t>
+            </a:r>
+            <a:r>
+              <a:rPr sz="1400" b="1">
+                <a:solidFill>
+                  <a:srgbClr val="0E2268"/>
+                </a:solidFill>
+                <a:latin typeface="Arial"/>
+              </a:rPr>
+              <a:t>)</a:t>
+            </a:r>
+          </a:p>
+          <a:p>
+            <a:pPr algn="l">
+              <a:spcAft>
+                <a:spcPts val="200"/>
+              </a:spcAft>
+            </a:pPr>
+            <a:r>
+              <a:rPr sz="1300" b="0">
+                <a:solidFill>
+                  <a:srgbClr val="1A1A1A"/>
+                </a:solidFill>
+                <a:latin typeface="Arial"/>
+              </a:rPr>
+              <a:t>ENA or PRBS/NRZ</a:t>
+            </a:r>
+          </a:p>
+        </p:txBody>
+      </p:sp>
+      <p:sp>
+        <p:nvSpPr>
+          <p:cNvPr id="6" name="Rounded Rectangle 5"/>
+          <p:cNvSpPr/>
+          <p:nvPr/>
+        </p:nvSpPr>
+        <p:spPr>
+          <a:xfrm>
+            <a:off x="457200" y="2743200"/>
+            <a:ext cx="2194560" cy="1005840"/>
+          </a:xfrm>
+          <a:prstGeom prst="roundRect">
+            <a:avLst>
+              <a:gd name="adj" fmla="val 6000"/>
+            </a:avLst>
+          </a:prstGeom>
+          <a:solidFill>
+            <a:srgbClr val="F1F3F8"/>
+          </a:solidFill>
+          <a:ln w="15875">
+            <a:solidFill>
+              <a:srgbClr val="D9DCE3"/>
+            </a:solidFill>
+          </a:ln>
+          <a:effectLst/>
+        </p:spPr>
+        <p:style>
+          <a:lnRef idx="1">
+            <a:schemeClr val="accent1"/>
+          </a:lnRef>
+          <a:fillRef idx="3">
+            <a:schemeClr val="accent1"/>
+          </a:fillRef>
+          <a:effectRef idx="2">
+            <a:schemeClr val="accent1"/>
+          </a:effectRef>
+          <a:fontRef idx="minor">
+            <a:schemeClr val="lt1"/>
+          </a:fontRef>
+        </p:style>
+        <p:txBody>
+          <a:bodyPr rtlCol="0" anchor="ctr"/>
+          <a:lstStyle/>
+          <a:p>
+            <a:pPr algn="ctr"/>
+          </a:p>
+        </p:txBody>
+      </p:sp>
+      <p:sp>
+        <p:nvSpPr>
           <p:cNvPr id="7" name="TextBox 6"/>
           <p:cNvSpPr txBox="1"/>
           <p:nvPr/>
@@ -8036,7 +9750,7 @@
 </p:sld>
 </file>
 
-<file path=ppt/slides/slide14.xml><?xml version="1.0" encoding="utf-8"?>
+<file path=ppt/slides/slide16.xml><?xml version="1.0" encoding="utf-8"?>
 <p:sld xmlns:a="http://schemas.openxmlformats.org/drawingml/2006/main" xmlns:p="http://schemas.openxmlformats.org/presentationml/2006/main" xmlns:r="http://schemas.openxmlformats.org/officeDocument/2006/relationships">
   <p:cSld>
     <p:spTree>

</xml_diff>